<commit_message>
update the readme and presentation with ablation study results
</commit_message>
<xml_diff>
--- a/presentation/ood_cores_mde_presentation.pptx
+++ b/presentation/ood_cores_mde_presentation.pptx
@@ -4,6 +4,9 @@
   <p:sldMasterIdLst>
     <p:sldMasterId id="2147483648" r:id="rId1"/>
   </p:sldMasterIdLst>
+  <p:notesMasterIdLst>
+    <p:notesMasterId r:id="rId11"/>
+  </p:notesMasterIdLst>
   <p:sldIdLst>
     <p:sldId id="256" r:id="rId2"/>
     <p:sldId id="257" r:id="rId3"/>
@@ -13,10 +16,8 @@
     <p:sldId id="261" r:id="rId7"/>
     <p:sldId id="262" r:id="rId8"/>
     <p:sldId id="263" r:id="rId9"/>
+    <p:sldId id="264" r:id="rId10"/>
   </p:sldIdLst>
-  <p:notesMasterIdLst>
-    <p:notesMasterId r:id="rId10"/>
-  </p:notesMasterIdLst>
   <p:sldSz cx="12192000" cy="6858000"/>
   <p:notesSz cx="6858000" cy="12192000"/>
   <p:defaultTextStyle>
@@ -111,13 +112,28 @@
       </a:defRPr>
     </a:lvl9pPr>
   </p:defaultTextStyle>
+  <p:extLst>
+    <p:ext uri="{EFAFB233-063F-42B5-8137-9DF3F51BA10A}">
+      <p15:sldGuideLst xmlns:p15="http://schemas.microsoft.com/office/powerpoint/2012/main"/>
+    </p:ext>
+  </p:extLst>
 </p:presentation>
 </file>
 
+<file path=ppt/revisionInfo.xml><?xml version="1.0" encoding="utf-8"?>
+<p1510:revInfo xmlns:a="http://schemas.openxmlformats.org/drawingml/2006/main" xmlns:r="http://schemas.openxmlformats.org/officeDocument/2006/relationships" xmlns:p1510="http://schemas.microsoft.com/office/powerpoint/2015/10/main">
+  <p1510:revLst>
+    <p1510:client id="{19C7E361-3E20-4A3A-8C50-48000D0D9AAB}" v="15" dt="2026-09-06T17:41:04.705"/>
+  </p1510:revLst>
+</p1510:revInfo>
+</file>
+
 <file path=ppt/charts/chart1.xml><?xml version="1.0" encoding="utf-8"?>
-<c:chartSpace xmlns:c="http://schemas.openxmlformats.org/drawingml/2006/chart" xmlns:a="http://schemas.openxmlformats.org/drawingml/2006/main" xmlns:r="http://schemas.openxmlformats.org/officeDocument/2006/relationships">
+<c:chartSpace xmlns:c="http://schemas.openxmlformats.org/drawingml/2006/chart" xmlns:a="http://schemas.openxmlformats.org/drawingml/2006/main" xmlns:r="http://schemas.openxmlformats.org/officeDocument/2006/relationships" xmlns:c16r2="http://schemas.microsoft.com/office/drawing/2015/06/chart">
   <c:date1904 val="0"/>
+  <c:lang val="en-US"/>
   <c:roundedCorners val="1"/>
+  <c:style val="2"/>
   <c:chart>
     <c:title>
       <c:tx>
@@ -134,7 +150,7 @@
               </a:defRPr>
             </a:pPr>
             <a:r>
-              <a:rPr sz="1300" b="0" i="0" u="none" strike="noStrike">
+              <a:rPr lang="en-US" sz="1300" b="0" i="0" u="none" strike="noStrike">
                 <a:solidFill>
                   <a:srgbClr val="21295C"/>
                 </a:solidFill>
@@ -145,7 +161,6 @@
           </a:p>
         </c:rich>
       </c:tx>
-      <c:layout/>
       <c:overlay val="0"/>
     </c:title>
     <c:autoTitleDeleted val="0"/>
@@ -164,7 +179,7 @@
               <c:strCache>
                 <c:ptCount val="1"/>
                 <c:pt idx="0">
-                  <c:v>Accuracy</c:v>
+                  <c:v>ResNet18</c:v>
                 </c:pt>
               </c:strCache>
             </c:strRef>
@@ -178,18 +193,26 @@
           <c:invertIfNegative val="0"/>
           <c:dLbls>
             <c:numFmt formatCode="0.000" sourceLinked="0"/>
+            <c:spPr>
+              <a:noFill/>
+              <a:ln>
+                <a:noFill/>
+              </a:ln>
+              <a:effectLst/>
+            </c:spPr>
             <c:txPr>
               <a:bodyPr/>
               <a:lstStyle/>
               <a:p>
                 <a:pPr>
-                  <a:defRPr b="0" i="0" strike="noStrike" sz="1100" u="none">
+                  <a:defRPr sz="1000" b="0" i="0" u="none" strike="noStrike">
                     <a:solidFill>
                       <a:srgbClr val="3A4652"/>
                     </a:solidFill>
                     <a:latin typeface="Calibri"/>
                   </a:defRPr>
                 </a:pPr>
+                <a:endParaRPr lang="en-US"/>
               </a:p>
             </c:txPr>
             <c:showLegendKey val="0"/>
@@ -199,25 +222,28 @@
             <c:showPercent val="0"/>
             <c:showBubbleSize val="0"/>
             <c:showLeaderLines val="0"/>
+            <c:extLst>
+              <c:ext xmlns:c15="http://schemas.microsoft.com/office/drawing/2012/chart" uri="{CE6537A1-D6FC-4f65-9D91-7224C49458BB}">
+                <c15:showLeaderLines val="0"/>
+              </c:ext>
+            </c:extLst>
           </c:dLbls>
           <c:cat>
-            <c:multiLvlStrRef>
+            <c:strRef>
               <c:f>Sheet1!$A$2:$A$4</c:f>
-              <c:multiLvlStrCache>
+              <c:strCache>
                 <c:ptCount val="3"/>
-                <c:lvl>
-                  <c:pt idx="0">
-                    <c:v>δ₁ &lt; 1.25</c:v>
-                  </c:pt>
-                  <c:pt idx="1">
-                    <c:v>δ₂ &lt; 1.25²</c:v>
-                  </c:pt>
-                  <c:pt idx="2">
-                    <c:v>δ₃ &lt; 1.25³</c:v>
-                  </c:pt>
-                </c:lvl>
-              </c:multiLvlStrCache>
-            </c:multiLvlStrRef>
+                <c:pt idx="0">
+                  <c:v>δ₁</c:v>
+                </c:pt>
+                <c:pt idx="1">
+                  <c:v>δ₂</c:v>
+                </c:pt>
+                <c:pt idx="2">
+                  <c:v>δ₃</c:v>
+                </c:pt>
+              </c:strCache>
+            </c:strRef>
           </c:cat>
           <c:val>
             <c:numRef>
@@ -226,47 +252,133 @@
                 <c:formatCode>General</c:formatCode>
                 <c:ptCount val="3"/>
                 <c:pt idx="0">
-                  <c:v>0.714</c:v>
+                  <c:v>0.71399999999999997</c:v>
                 </c:pt>
                 <c:pt idx="1">
-                  <c:v>0.916</c:v>
+                  <c:v>0.92400000000000004</c:v>
                 </c:pt>
                 <c:pt idx="2">
-                  <c:v>0.971</c:v>
+                  <c:v>0.97799999999999998</c:v>
                 </c:pt>
               </c:numCache>
             </c:numRef>
           </c:val>
+          <c:extLst>
+            <c:ext xmlns:c16="http://schemas.microsoft.com/office/drawing/2014/chart" uri="{C3380CC4-5D6E-409C-BE32-E72D297353CC}">
+              <c16:uniqueId val="{00000000-4426-4931-A5EF-3E01BA42DED5}"/>
+            </c:ext>
+          </c:extLst>
+        </c:ser>
+        <c:ser>
+          <c:idx val="1"/>
+          <c:order val="1"/>
+          <c:tx>
+            <c:strRef>
+              <c:f>Sheet1!$C$1</c:f>
+              <c:strCache>
+                <c:ptCount val="1"/>
+                <c:pt idx="0">
+                  <c:v>ResNet34</c:v>
+                </c:pt>
+              </c:strCache>
+            </c:strRef>
+          </c:tx>
+          <c:spPr>
+            <a:solidFill>
+              <a:srgbClr val="E8A33D"/>
+            </a:solidFill>
+            <a:effectLst/>
+          </c:spPr>
+          <c:invertIfNegative val="0"/>
+          <c:dLbls>
+            <c:numFmt formatCode="0.000" sourceLinked="0"/>
+            <c:spPr>
+              <a:noFill/>
+              <a:ln>
+                <a:noFill/>
+              </a:ln>
+              <a:effectLst/>
+            </c:spPr>
+            <c:txPr>
+              <a:bodyPr/>
+              <a:lstStyle/>
+              <a:p>
+                <a:pPr>
+                  <a:defRPr sz="1000" b="0" i="0" u="none" strike="noStrike">
+                    <a:solidFill>
+                      <a:srgbClr val="3A4652"/>
+                    </a:solidFill>
+                    <a:latin typeface="Calibri"/>
+                  </a:defRPr>
+                </a:pPr>
+                <a:endParaRPr lang="en-US"/>
+              </a:p>
+            </c:txPr>
+            <c:showLegendKey val="0"/>
+            <c:showVal val="1"/>
+            <c:showCatName val="0"/>
+            <c:showSerName val="0"/>
+            <c:showPercent val="0"/>
+            <c:showBubbleSize val="0"/>
+            <c:showLeaderLines val="0"/>
+            <c:extLst>
+              <c:ext xmlns:c15="http://schemas.microsoft.com/office/drawing/2012/chart" uri="{CE6537A1-D6FC-4f65-9D91-7224C49458BB}">
+                <c15:showLeaderLines val="0"/>
+              </c:ext>
+            </c:extLst>
+          </c:dLbls>
+          <c:cat>
+            <c:strRef>
+              <c:f>Sheet1!$A$2:$A$4</c:f>
+              <c:strCache>
+                <c:ptCount val="3"/>
+                <c:pt idx="0">
+                  <c:v>δ₁</c:v>
+                </c:pt>
+                <c:pt idx="1">
+                  <c:v>δ₂</c:v>
+                </c:pt>
+                <c:pt idx="2">
+                  <c:v>δ₃</c:v>
+                </c:pt>
+              </c:strCache>
+            </c:strRef>
+          </c:cat>
+          <c:val>
+            <c:numRef>
+              <c:f>Sheet1!$C$2:$C$4</c:f>
+              <c:numCache>
+                <c:formatCode>General</c:formatCode>
+                <c:ptCount val="3"/>
+                <c:pt idx="0">
+                  <c:v>0.78100000000000003</c:v>
+                </c:pt>
+                <c:pt idx="1">
+                  <c:v>0.94599999999999995</c:v>
+                </c:pt>
+                <c:pt idx="2">
+                  <c:v>0.98599999999999999</c:v>
+                </c:pt>
+              </c:numCache>
+            </c:numRef>
+          </c:val>
+          <c:extLst>
+            <c:ext xmlns:c16="http://schemas.microsoft.com/office/drawing/2014/chart" uri="{C3380CC4-5D6E-409C-BE32-E72D297353CC}">
+              <c16:uniqueId val="{00000001-4426-4931-A5EF-3E01BA42DED5}"/>
+            </c:ext>
+          </c:extLst>
         </c:ser>
         <c:dLbls>
-          <c:numFmt formatCode="0.000" sourceLinked="0"/>
-          <c:txPr>
-            <a:bodyPr/>
-            <a:lstStyle/>
-            <a:p>
-              <a:pPr>
-                <a:defRPr b="0" i="0" strike="noStrike" sz="1100" u="none">
-                  <a:solidFill>
-                    <a:srgbClr val="3A4652"/>
-                  </a:solidFill>
-                  <a:latin typeface="Calibri"/>
-                </a:defRPr>
-              </a:pPr>
-            </a:p>
-          </c:txPr>
           <c:showLegendKey val="0"/>
           <c:showVal val="1"/>
           <c:showCatName val="0"/>
           <c:showSerName val="0"/>
           <c:showPercent val="0"/>
           <c:showBubbleSize val="0"/>
-          <c:showLeaderLines val="0"/>
         </c:dLbls>
         <c:gapWidth val="150"/>
-        <c:overlap val="0"/>
         <c:axId val="2094734554"/>
         <c:axId val="2094734552"/>
-        <c:axId val="2094734556"/>
       </c:barChart>
       <c:catAx>
         <c:axId val="2094734554"/>
@@ -307,13 +419,14 @@
         <c:crosses val="autoZero"/>
         <c:auto val="1"/>
         <c:lblAlgn val="ctr"/>
+        <c:lblOffset val="100"/>
         <c:noMultiLvlLbl val="1"/>
       </c:catAx>
       <c:valAx>
         <c:axId val="2094734552"/>
         <c:scaling>
           <c:orientation val="minMax"/>
-          <c:max val="1.1"/>
+          <c:max val="1.2"/>
           <c:min val="0"/>
         </c:scaling>
         <c:delete val="0"/>
@@ -369,8 +482,26 @@
         <a:effectLst/>
       </c:spPr>
     </c:plotArea>
+    <c:legend>
+      <c:legendPos val="b"/>
+      <c:overlay val="0"/>
+      <c:txPr>
+        <a:bodyPr/>
+        <a:lstStyle/>
+        <a:p>
+          <a:pPr>
+            <a:defRPr sz="1100">
+              <a:latin typeface="Calibri"/>
+              <a:cs typeface="Calibri"/>
+            </a:defRPr>
+          </a:pPr>
+          <a:endParaRPr lang="en-US"/>
+        </a:p>
+      </c:txPr>
+    </c:legend>
     <c:plotVisOnly val="1"/>
     <c:dispBlanksAs val="span"/>
+    <c:showDLblsOverMax val="1"/>
   </c:chart>
   <c:spPr>
     <a:noFill/>
@@ -386,9 +517,11 @@
 </file>
 
 <file path=ppt/charts/chart2.xml><?xml version="1.0" encoding="utf-8"?>
-<c:chartSpace xmlns:c="http://schemas.openxmlformats.org/drawingml/2006/chart" xmlns:a="http://schemas.openxmlformats.org/drawingml/2006/main" xmlns:r="http://schemas.openxmlformats.org/officeDocument/2006/relationships">
+<c:chartSpace xmlns:c="http://schemas.openxmlformats.org/drawingml/2006/chart" xmlns:a="http://schemas.openxmlformats.org/drawingml/2006/main" xmlns:r="http://schemas.openxmlformats.org/officeDocument/2006/relationships" xmlns:c16r2="http://schemas.microsoft.com/office/drawing/2015/06/chart">
   <c:date1904 val="0"/>
+  <c:lang val="en-US"/>
   <c:roundedCorners val="1"/>
+  <c:style val="2"/>
   <c:chart>
     <c:title>
       <c:tx>
@@ -405,7 +538,7 @@
               </a:defRPr>
             </a:pPr>
             <a:r>
-              <a:rPr sz="1300" b="0" i="0" u="none" strike="noStrike">
+              <a:rPr lang="en-US" sz="1300" b="0" i="0" u="none" strike="noStrike">
                 <a:solidFill>
                   <a:srgbClr val="21295C"/>
                 </a:solidFill>
@@ -416,7 +549,6 @@
           </a:p>
         </c:rich>
       </c:tx>
-      <c:layout/>
       <c:overlay val="0"/>
     </c:title>
     <c:autoTitleDeleted val="0"/>
@@ -435,7 +567,7 @@
               <c:strCache>
                 <c:ptCount val="1"/>
                 <c:pt idx="0">
-                  <c:v>AUROC</c:v>
+                  <c:v>ResNet18</c:v>
                 </c:pt>
               </c:strCache>
             </c:strRef>
@@ -449,18 +581,26 @@
           <c:invertIfNegative val="0"/>
           <c:dLbls>
             <c:numFmt formatCode="0.000" sourceLinked="0"/>
+            <c:spPr>
+              <a:noFill/>
+              <a:ln>
+                <a:noFill/>
+              </a:ln>
+              <a:effectLst/>
+            </c:spPr>
             <c:txPr>
               <a:bodyPr/>
               <a:lstStyle/>
               <a:p>
                 <a:pPr>
-                  <a:defRPr b="0" i="0" strike="noStrike" sz="1100" u="none">
+                  <a:defRPr sz="900" b="0" i="0" u="none" strike="noStrike">
                     <a:solidFill>
                       <a:srgbClr val="3A4652"/>
                     </a:solidFill>
                     <a:latin typeface="Calibri"/>
                   </a:defRPr>
                 </a:pPr>
+                <a:endParaRPr lang="en-US"/>
               </a:p>
             </c:txPr>
             <c:showLegendKey val="0"/>
@@ -470,86 +610,34 @@
             <c:showPercent val="0"/>
             <c:showBubbleSize val="0"/>
             <c:showLeaderLines val="0"/>
+            <c:extLst>
+              <c:ext xmlns:c15="http://schemas.microsoft.com/office/drawing/2012/chart" uri="{CE6537A1-D6FC-4f65-9D91-7224C49458BB}">
+                <c15:showLeaderLines val="0"/>
+              </c:ext>
+            </c:extLst>
           </c:dLbls>
-          <c:dPt>
-            <c:idx val="0"/>
-            <c:invertIfNegative val="0"/>
-            <c:bubble3D val="0"/>
-            <c:spPr>
-              <a:solidFill>
-                <a:srgbClr val="1C7293"/>
-              </a:solidFill>
-              <a:effectLst/>
-            </c:spPr>
-          </c:dPt>
-          <c:dPt>
-            <c:idx val="1"/>
-            <c:invertIfNegative val="0"/>
-            <c:bubble3D val="0"/>
-            <c:spPr>
-              <a:solidFill>
-                <a:srgbClr val="1C7293"/>
-              </a:solidFill>
-              <a:effectLst/>
-            </c:spPr>
-          </c:dPt>
-          <c:dPt>
-            <c:idx val="2"/>
-            <c:invertIfNegative val="0"/>
-            <c:bubble3D val="0"/>
-            <c:spPr>
-              <a:solidFill>
-                <a:srgbClr val="1C7293"/>
-              </a:solidFill>
-              <a:effectLst/>
-            </c:spPr>
-          </c:dPt>
-          <c:dPt>
-            <c:idx val="3"/>
-            <c:invertIfNegative val="0"/>
-            <c:bubble3D val="0"/>
-            <c:spPr>
-              <a:solidFill>
-                <a:srgbClr val="1C7293"/>
-              </a:solidFill>
-              <a:effectLst/>
-            </c:spPr>
-          </c:dPt>
-          <c:dPt>
-            <c:idx val="4"/>
-            <c:invertIfNegative val="0"/>
-            <c:bubble3D val="0"/>
-            <c:spPr>
-              <a:solidFill>
-                <a:srgbClr val="E8A33D"/>
-              </a:solidFill>
-              <a:effectLst/>
-            </c:spPr>
-          </c:dPt>
           <c:cat>
-            <c:multiLvlStrRef>
+            <c:strRef>
               <c:f>Sheet1!$A$2:$A$6</c:f>
-              <c:multiLvlStrCache>
+              <c:strCache>
                 <c:ptCount val="5"/>
-                <c:lvl>
-                  <c:pt idx="0">
-                    <c:v>Layer 1</c:v>
-                  </c:pt>
-                  <c:pt idx="1">
-                    <c:v>Layer 2</c:v>
-                  </c:pt>
-                  <c:pt idx="2">
-                    <c:v>Layer 3</c:v>
-                  </c:pt>
-                  <c:pt idx="3">
-                    <c:v>Layer 4</c:v>
-                  </c:pt>
-                  <c:pt idx="4">
-                    <c:v>Combined</c:v>
-                  </c:pt>
-                </c:lvl>
-              </c:multiLvlStrCache>
-            </c:multiLvlStrRef>
+                <c:pt idx="0">
+                  <c:v>Layer 1</c:v>
+                </c:pt>
+                <c:pt idx="1">
+                  <c:v>Layer 2</c:v>
+                </c:pt>
+                <c:pt idx="2">
+                  <c:v>Layer 3</c:v>
+                </c:pt>
+                <c:pt idx="3">
+                  <c:v>Layer 4</c:v>
+                </c:pt>
+                <c:pt idx="4">
+                  <c:v>Combined</c:v>
+                </c:pt>
+              </c:strCache>
+            </c:strRef>
           </c:cat>
           <c:val>
             <c:numRef>
@@ -558,53 +646,151 @@
                 <c:formatCode>General</c:formatCode>
                 <c:ptCount val="5"/>
                 <c:pt idx="0">
-                  <c:v>0.895</c:v>
+                  <c:v>0.86899999999999999</c:v>
                 </c:pt>
                 <c:pt idx="1">
-                  <c:v>0.961</c:v>
+                  <c:v>0.96799999999999997</c:v>
                 </c:pt>
                 <c:pt idx="2">
-                  <c:v>0.973</c:v>
+                  <c:v>0.96299999999999997</c:v>
                 </c:pt>
                 <c:pt idx="3">
-                  <c:v>0.757</c:v>
+                  <c:v>0.90400000000000003</c:v>
                 </c:pt>
                 <c:pt idx="4">
-                  <c:v>0.984</c:v>
+                  <c:v>0.98599999999999999</c:v>
                 </c:pt>
               </c:numCache>
             </c:numRef>
           </c:val>
+          <c:extLst>
+            <c:ext xmlns:c16="http://schemas.microsoft.com/office/drawing/2014/chart" uri="{C3380CC4-5D6E-409C-BE32-E72D297353CC}">
+              <c16:uniqueId val="{00000000-B14A-43DB-9A97-9F07DB1F430A}"/>
+            </c:ext>
+          </c:extLst>
+        </c:ser>
+        <c:ser>
+          <c:idx val="1"/>
+          <c:order val="1"/>
+          <c:tx>
+            <c:strRef>
+              <c:f>Sheet1!$C$1</c:f>
+              <c:strCache>
+                <c:ptCount val="1"/>
+                <c:pt idx="0">
+                  <c:v>ResNet34</c:v>
+                </c:pt>
+              </c:strCache>
+            </c:strRef>
+          </c:tx>
+          <c:spPr>
+            <a:solidFill>
+              <a:srgbClr val="E8A33D"/>
+            </a:solidFill>
+            <a:effectLst/>
+          </c:spPr>
+          <c:invertIfNegative val="0"/>
+          <c:dLbls>
+            <c:numFmt formatCode="0.000" sourceLinked="0"/>
+            <c:spPr>
+              <a:noFill/>
+              <a:ln>
+                <a:noFill/>
+              </a:ln>
+              <a:effectLst/>
+            </c:spPr>
+            <c:txPr>
+              <a:bodyPr/>
+              <a:lstStyle/>
+              <a:p>
+                <a:pPr>
+                  <a:defRPr sz="900" b="0" i="0" u="none" strike="noStrike">
+                    <a:solidFill>
+                      <a:srgbClr val="3A4652"/>
+                    </a:solidFill>
+                    <a:latin typeface="Calibri"/>
+                  </a:defRPr>
+                </a:pPr>
+                <a:endParaRPr lang="en-US"/>
+              </a:p>
+            </c:txPr>
+            <c:showLegendKey val="0"/>
+            <c:showVal val="1"/>
+            <c:showCatName val="0"/>
+            <c:showSerName val="0"/>
+            <c:showPercent val="0"/>
+            <c:showBubbleSize val="0"/>
+            <c:showLeaderLines val="0"/>
+            <c:extLst>
+              <c:ext xmlns:c15="http://schemas.microsoft.com/office/drawing/2012/chart" uri="{CE6537A1-D6FC-4f65-9D91-7224C49458BB}">
+                <c15:showLeaderLines val="0"/>
+              </c:ext>
+            </c:extLst>
+          </c:dLbls>
+          <c:cat>
+            <c:strRef>
+              <c:f>Sheet1!$A$2:$A$6</c:f>
+              <c:strCache>
+                <c:ptCount val="5"/>
+                <c:pt idx="0">
+                  <c:v>Layer 1</c:v>
+                </c:pt>
+                <c:pt idx="1">
+                  <c:v>Layer 2</c:v>
+                </c:pt>
+                <c:pt idx="2">
+                  <c:v>Layer 3</c:v>
+                </c:pt>
+                <c:pt idx="3">
+                  <c:v>Layer 4</c:v>
+                </c:pt>
+                <c:pt idx="4">
+                  <c:v>Combined</c:v>
+                </c:pt>
+              </c:strCache>
+            </c:strRef>
+          </c:cat>
+          <c:val>
+            <c:numRef>
+              <c:f>Sheet1!$C$2:$C$6</c:f>
+              <c:numCache>
+                <c:formatCode>General</c:formatCode>
+                <c:ptCount val="5"/>
+                <c:pt idx="0">
+                  <c:v>0.93300000000000005</c:v>
+                </c:pt>
+                <c:pt idx="1">
+                  <c:v>0.94099999999999995</c:v>
+                </c:pt>
+                <c:pt idx="2">
+                  <c:v>0.78300000000000003</c:v>
+                </c:pt>
+                <c:pt idx="3">
+                  <c:v>0.67600000000000005</c:v>
+                </c:pt>
+                <c:pt idx="4">
+                  <c:v>0.95599999999999996</c:v>
+                </c:pt>
+              </c:numCache>
+            </c:numRef>
+          </c:val>
+          <c:extLst>
+            <c:ext xmlns:c16="http://schemas.microsoft.com/office/drawing/2014/chart" uri="{C3380CC4-5D6E-409C-BE32-E72D297353CC}">
+              <c16:uniqueId val="{00000001-B14A-43DB-9A97-9F07DB1F430A}"/>
+            </c:ext>
+          </c:extLst>
         </c:ser>
         <c:dLbls>
-          <c:numFmt formatCode="0.000" sourceLinked="0"/>
-          <c:txPr>
-            <a:bodyPr/>
-            <a:lstStyle/>
-            <a:p>
-              <a:pPr>
-                <a:defRPr b="0" i="0" strike="noStrike" sz="1100" u="none">
-                  <a:solidFill>
-                    <a:srgbClr val="3A4652"/>
-                  </a:solidFill>
-                  <a:latin typeface="Calibri"/>
-                </a:defRPr>
-              </a:pPr>
-            </a:p>
-          </c:txPr>
           <c:showLegendKey val="0"/>
           <c:showVal val="1"/>
           <c:showCatName val="0"/>
           <c:showSerName val="0"/>
           <c:showPercent val="0"/>
           <c:showBubbleSize val="0"/>
-          <c:showLeaderLines val="0"/>
         </c:dLbls>
         <c:gapWidth val="150"/>
-        <c:overlap val="0"/>
         <c:axId val="2094734554"/>
         <c:axId val="2094734552"/>
-        <c:axId val="2094734556"/>
       </c:barChart>
       <c:catAx>
         <c:axId val="2094734554"/>
@@ -631,7 +817,7 @@
           <a:lstStyle/>
           <a:p>
             <a:pPr>
-              <a:defRPr sz="1200" b="0" i="0" u="none" strike="noStrike">
+              <a:defRPr sz="1100" b="0" i="0" u="none" strike="noStrike">
                 <a:solidFill>
                   <a:srgbClr val="3A4652"/>
                 </a:solidFill>
@@ -645,13 +831,14 @@
         <c:crosses val="autoZero"/>
         <c:auto val="1"/>
         <c:lblAlgn val="ctr"/>
+        <c:lblOffset val="100"/>
         <c:noMultiLvlLbl val="1"/>
       </c:catAx>
       <c:valAx>
         <c:axId val="2094734552"/>
         <c:scaling>
           <c:orientation val="minMax"/>
-          <c:max val="1"/>
+          <c:max val="1.05"/>
           <c:min val="0.5"/>
         </c:scaling>
         <c:delete val="0"/>
@@ -707,8 +894,26 @@
         <a:effectLst/>
       </c:spPr>
     </c:plotArea>
+    <c:legend>
+      <c:legendPos val="b"/>
+      <c:overlay val="0"/>
+      <c:txPr>
+        <a:bodyPr/>
+        <a:lstStyle/>
+        <a:p>
+          <a:pPr>
+            <a:defRPr sz="1100">
+              <a:latin typeface="Calibri"/>
+              <a:cs typeface="Calibri"/>
+            </a:defRPr>
+          </a:pPr>
+          <a:endParaRPr lang="en-US"/>
+        </a:p>
+      </c:txPr>
+    </c:legend>
     <c:plotVisOnly val="1"/>
     <c:dispBlanksAs val="span"/>
+    <c:showDLblsOverMax val="1"/>
   </c:chart>
   <c:spPr>
     <a:noFill/>
@@ -758,7 +963,7 @@
         <p:spPr>
           <a:xfrm>
             <a:off x="0" y="0"/>
-            <a:ext cx="2971800" cy="458788"/>
+            <a:ext cx="2971800" cy="611188"/>
           </a:xfrm>
           <a:prstGeom prst="rect">
             <a:avLst/>
@@ -789,7 +994,7 @@
         <p:spPr>
           <a:xfrm>
             <a:off x="3884613" y="0"/>
-            <a:ext cx="2971800" cy="458788"/>
+            <a:ext cx="2971800" cy="611188"/>
           </a:xfrm>
           <a:prstGeom prst="rect">
             <a:avLst/>
@@ -803,9 +1008,8 @@
             </a:lvl1pPr>
           </a:lstStyle>
           <a:p>
-            <a:fld id="{5282F153-3F37-0F45-9E97-73ACFA13230C}" type="datetimeFigureOut">
-              <a:rPr lang="en-US"/>
-              <a:t>7/23/19</a:t>
+            <a:fld id="{CFD1CD69-EB78-4CBF-A4B3-DE2C3F68389E}" type="datetimeFigureOut">
+              <a:t>9/6/2026</a:t>
             </a:fld>
             <a:endParaRPr lang="en-US"/>
           </a:p>
@@ -823,8 +1027,8 @@
         </p:nvSpPr>
         <p:spPr>
           <a:xfrm>
-            <a:off x="685800" y="1143000"/>
-            <a:ext cx="5486400" cy="3086100"/>
+            <a:off x="-228600" y="1524000"/>
+            <a:ext cx="7315200" cy="4114800"/>
           </a:xfrm>
           <a:prstGeom prst="rect">
             <a:avLst/>
@@ -856,8 +1060,8 @@
         </p:nvSpPr>
         <p:spPr>
           <a:xfrm>
-            <a:off x="685800" y="4400550"/>
-            <a:ext cx="5486400" cy="3600450"/>
+            <a:off x="685800" y="5867400"/>
+            <a:ext cx="5486400" cy="4800600"/>
           </a:xfrm>
           <a:prstGeom prst="rect">
             <a:avLst/>
@@ -915,8 +1119,8 @@
         </p:nvSpPr>
         <p:spPr>
           <a:xfrm>
-            <a:off x="0" y="8685213"/>
-            <a:ext cx="2971800" cy="458787"/>
+            <a:off x="0" y="11580813"/>
+            <a:ext cx="2971800" cy="611187"/>
           </a:xfrm>
           <a:prstGeom prst="rect">
             <a:avLst/>
@@ -946,8 +1150,8 @@
         </p:nvSpPr>
         <p:spPr>
           <a:xfrm>
-            <a:off x="3884613" y="8685213"/>
-            <a:ext cx="2971800" cy="458787"/>
+            <a:off x="3884613" y="11580813"/>
+            <a:ext cx="2971800" cy="611187"/>
           </a:xfrm>
           <a:prstGeom prst="rect">
             <a:avLst/>
@@ -961,8 +1165,7 @@
             </a:lvl1pPr>
           </a:lstStyle>
           <a:p>
-            <a:fld id="{CE5E9CC1-C706-0F49-92D6-E571CC5EEA8F}" type="slidenum">
-              <a:rPr lang="en-US"/>
+            <a:fld id="{EA0A9A10-D592-4121-8ACC-018E583667ED}" type="slidenum">
               <a:t>‹#›</a:t>
             </a:fld>
             <a:endParaRPr lang="en-US"/>
@@ -972,7 +1175,7 @@
     </p:spTree>
     <p:extLst>
       <p:ext uri="{BB962C8B-B14F-4D97-AF65-F5344CB8AC3E}">
-        <p14:creationId xmlns:p14="http://schemas.microsoft.com/office/powerpoint/2010/main" val="1024086991"/>
+        <p14:creationId xmlns:p14="http://schemas.microsoft.com/office/powerpoint/2010/main" val="1338002205"/>
       </p:ext>
     </p:extLst>
   </p:cSld>
@@ -1118,9 +1321,8 @@
           <a:p>
             <a:r>
               <a:rPr lang="en-US" dirty="0"/>
-              <a:t>Project 2. A depth estimation model trained only on indoor scenes; convolutional responses are then used to flag inputs that fall outside that distribution. No retraining and no OOD data needed at calibration time.</a:t>
-            </a:r>
-            <a:endParaRPr lang="en-US" dirty="0"/>
+              <a:t>Project 2. A depth model trained only on indoor scenes; its convolutional responses are then read to flag inputs outside that distribution. No retraining, and no OOD data needed at calibration time.</a:t>
+            </a:r>
           </a:p>
         </p:txBody>
       </p:sp>
@@ -1206,9 +1408,8 @@
           <a:p>
             <a:r>
               <a:rPr lang="en-US" dirty="0"/>
-              <a:t>The core problem is that failure is silent. The model has no way to express that an input is unfamiliar, and dense prediction means the output always looks complete.</a:t>
-            </a:r>
-            <a:endParaRPr lang="en-US" dirty="0"/>
+              <a:t>Failure is silent. The model cannot express that an input is unfamiliar, and dense prediction means the output always looks complete.</a:t>
+            </a:r>
           </a:p>
         </p:txBody>
       </p:sp>
@@ -1294,9 +1495,8 @@
           <a:p>
             <a:r>
               <a:rPr lang="en-US" dirty="0"/>
-              <a:t>Emphasise step 3 — that is where the contribution sits. Steps 1, 2 and 4 are standard.</a:t>
-            </a:r>
-            <a:endParaRPr lang="en-US" dirty="0"/>
+              <a:t>Step 3 is where the contribution sits. Steps 1, 2 and 4 are standard.</a:t>
+            </a:r>
           </a:p>
         </p:txBody>
       </p:sp>
@@ -1382,9 +1582,8 @@
           <a:p>
             <a:r>
               <a:rPr lang="en-US" dirty="0"/>
-              <a:t>The three decisions at the bottom are the ones most likely to be questioned. Each has a one-sentence justification.</a:t>
-            </a:r>
-            <a:endParaRPr lang="en-US" dirty="0"/>
+              <a:t>The three decisions at the bottom are the most likely to be questioned. Each has a one-sentence justification.</a:t>
+            </a:r>
           </a:p>
         </p:txBody>
       </p:sp>
@@ -1470,9 +1669,8 @@
           <a:p>
             <a:r>
               <a:rPr lang="en-US" dirty="0"/>
-              <a:t>Depth accuracy is a means, not the goal. What matters is that the model genuinely learned indoor structure — validation loss fell and then stabilised.</a:t>
-            </a:r>
-            <a:endParaRPr lang="en-US" dirty="0"/>
+              <a:t>Depth accuracy is a means, not the goal. What matters is that both models genuinely learned indoor structure.</a:t>
+            </a:r>
           </a:p>
         </p:txBody>
       </p:sp>
@@ -1558,9 +1756,8 @@
           <a:p>
             <a:r>
               <a:rPr lang="en-US" dirty="0"/>
-              <a:t>This is the centre of the project. The magnitude formulation gave AUROC 0.31 — real separation, wrong direction. Switching to the spread across channels gave 0.97. The percentile choice is justified by the resolution difference between layers.</a:t>
-            </a:r>
-            <a:endParaRPr lang="en-US" dirty="0"/>
+              <a:t>This is the centre of the project. The magnitude formulation gave 0.31 — real separation, wrong direction. Switching to spread across channels gave 0.97. The percentile choice is justified by the resolution difference between layers.</a:t>
+            </a:r>
           </a:p>
         </p:txBody>
       </p:sp>
@@ -1646,9 +1843,8 @@
           <a:p>
             <a:r>
               <a:rPr lang="en-US" dirty="0"/>
-              <a:t>Layer 3 outperforming layer 4 is the interesting ablation result — the deepest features are the most task-specialised and apparently the least useful for distribution shift.</a:t>
-            </a:r>
-            <a:endParaRPr lang="en-US" dirty="0"/>
+              <a:t>The layer migration is the key ablation result. On the deeper backbone the OOD signal shifts toward shallow layers — deep features become more task-specialised and less sensitive to distribution shift.</a:t>
+            </a:r>
           </a:p>
         </p:txBody>
       </p:sp>
@@ -1734,9 +1930,8 @@
           <a:p>
             <a:r>
               <a:rPr lang="en-US" dirty="0"/>
-              <a:t>Be direct about the limitation: indoor versus outdoor is a very wide gap, and part of the separation may come from texture statistics rather than semantic novelty. That is honest and it is the obvious question.</a:t>
-            </a:r>
-            <a:endParaRPr lang="en-US" dirty="0"/>
+              <a:t>Two independent confirmations of the same relationship. This is the most interesting result — it suggests the detector is reading how tightly the model has fitted its training distribution.</a:t>
+            </a:r>
           </a:p>
         </p:txBody>
       </p:sp>
@@ -1758,6 +1953,93 @@
             <a:fld id="{F7021451-1387-4CA6-816F-3879F97B5CBC}" type="slidenum">
               <a:rPr lang="en-US"/>
               <a:t>8</a:t>
+            </a:fld>
+            <a:endParaRPr lang="en-US"/>
+          </a:p>
+        </p:txBody>
+      </p:sp>
+    </p:spTree>
+    <p:extLst>
+      <p:ext uri="{BB962C8B-B14F-4D97-AF65-F5344CB8AC3E}">
+        <p14:creationId xmlns:p14="http://schemas.microsoft.com/office/powerpoint/2010/main" val="1024086991"/>
+      </p:ext>
+    </p:extLst>
+  </p:cSld>
+  <p:clrMapOvr>
+    <a:masterClrMapping/>
+  </p:clrMapOvr>
+</p:notes>
+</file>
+
+<file path=ppt/notesSlides/notesSlide9.xml><?xml version="1.0" encoding="utf-8"?>
+<p:notes xmlns:a="http://schemas.openxmlformats.org/drawingml/2006/main" xmlns:r="http://schemas.openxmlformats.org/officeDocument/2006/relationships" xmlns:p="http://schemas.openxmlformats.org/presentationml/2006/main">
+  <p:cSld>
+    <p:spTree>
+      <p:nvGrpSpPr>
+        <p:cNvPr id="1" name=""/>
+        <p:cNvGrpSpPr/>
+        <p:nvPr/>
+      </p:nvGrpSpPr>
+      <p:grpSpPr>
+        <a:xfrm>
+          <a:off x="0" y="0"/>
+          <a:ext cx="0" cy="0"/>
+          <a:chOff x="0" y="0"/>
+          <a:chExt cx="0" cy="0"/>
+        </a:xfrm>
+      </p:grpSpPr>
+      <p:sp>
+        <p:nvSpPr>
+          <p:cNvPr id="2" name="Slide Image Placeholder 1"/>
+          <p:cNvSpPr>
+            <a:spLocks noGrp="1" noRot="1" noChangeAspect="1"/>
+          </p:cNvSpPr>
+          <p:nvPr>
+            <p:ph type="sldImg"/>
+          </p:nvPr>
+        </p:nvSpPr>
+        <p:spPr/>
+      </p:sp>
+      <p:sp>
+        <p:nvSpPr>
+          <p:cNvPr id="3" name="Notes Placeholder 2"/>
+          <p:cNvSpPr>
+            <a:spLocks noGrp="1"/>
+          </p:cNvSpPr>
+          <p:nvPr>
+            <p:ph type="body" idx="1"/>
+          </p:nvPr>
+        </p:nvSpPr>
+        <p:spPr/>
+        <p:txBody>
+          <a:bodyPr/>
+          <a:lstStyle/>
+          <a:p>
+            <a:r>
+              <a:rPr lang="en-US" dirty="0"/>
+              <a:t>Be direct about the limitations. Indoor versus outdoor is a very wide gap, and part of the separation may come from texture statistics rather than semantic novelty. Raising it yourself is stronger than having it raised at you.</a:t>
+            </a:r>
+          </a:p>
+        </p:txBody>
+      </p:sp>
+      <p:sp>
+        <p:nvSpPr>
+          <p:cNvPr id="4" name="Slide Number Placeholder 3"/>
+          <p:cNvSpPr>
+            <a:spLocks noGrp="1"/>
+          </p:cNvSpPr>
+          <p:nvPr>
+            <p:ph type="sldNum" sz="quarter" idx="10"/>
+          </p:nvPr>
+        </p:nvSpPr>
+        <p:spPr/>
+        <p:txBody>
+          <a:bodyPr/>
+          <a:lstStyle/>
+          <a:p>
+            <a:fld id="{F7021451-1387-4CA6-816F-3879F97B5CBC}" type="slidenum">
+              <a:rPr lang="en-US"/>
+              <a:t>9</a:t>
             </a:fld>
             <a:endParaRPr lang="en-US"/>
           </a:p>
@@ -1809,6 +2091,11 @@
 <file path=ppt/slideMasters/slideMaster1.xml><?xml version="1.0" encoding="utf-8"?>
 <p:sldMaster xmlns:a="http://schemas.openxmlformats.org/drawingml/2006/main" xmlns:r="http://schemas.openxmlformats.org/officeDocument/2006/relationships" xmlns:p="http://schemas.openxmlformats.org/presentationml/2006/main">
   <p:cSld>
+    <p:bg>
+      <p:bgRef idx="1001">
+        <a:schemeClr val="bg1"/>
+      </p:bgRef>
+    </p:bg>
     <p:spTree>
       <p:nvGrpSpPr>
         <p:cNvPr id="1" name=""/>
@@ -2091,6 +2378,7 @@
         <a:solidFill>
           <a:srgbClr val="21295C"/>
         </a:solidFill>
+        <a:effectLst/>
       </p:bgPr>
     </p:bg>
     <p:spTree>
@@ -2128,7 +2416,7 @@
           <a:bodyPr wrap="square" lIns="0" tIns="0" rIns="0" bIns="0" rtlCol="0" anchor="ctr"/>
           <a:lstStyle/>
           <a:p>
-            <a:pPr indent="0" marL="0">
+            <a:pPr marL="0" indent="0">
               <a:buNone/>
             </a:pPr>
             <a:r>
@@ -2167,7 +2455,7 @@
           <a:bodyPr wrap="square" lIns="0" tIns="0" rIns="0" bIns="0" rtlCol="0" anchor="ctr"/>
           <a:lstStyle/>
           <a:p>
-            <a:pPr indent="0" marL="0">
+            <a:pPr marL="0" indent="0">
               <a:buNone/>
             </a:pPr>
             <a:r>
@@ -2206,7 +2494,7 @@
           <a:bodyPr wrap="square" lIns="0" tIns="0" rIns="0" bIns="0" rtlCol="0" anchor="ctr"/>
           <a:lstStyle/>
           <a:p>
-            <a:pPr indent="0" marL="0">
+            <a:pPr marL="0" indent="0">
               <a:buNone/>
             </a:pPr>
             <a:r>
@@ -2245,21 +2533,16 @@
           <a:bodyPr wrap="square" lIns="0" tIns="0" rIns="0" bIns="0" rtlCol="0" anchor="ctr"/>
           <a:lstStyle/>
           <a:p>
-            <a:pPr indent="0" marL="0">
-              <a:buNone/>
-            </a:pPr>
             <a:r>
               <a:rPr lang="en-US" sz="1600" dirty="0">
                 <a:solidFill>
                   <a:srgbClr val="CADCFC"/>
                 </a:solidFill>
-                <a:latin typeface="Calibri" pitchFamily="34" charset="0"/>
-                <a:ea typeface="Calibri" pitchFamily="34" charset="-122"/>
-                <a:cs typeface="Calibri" pitchFamily="34" charset="-120"/>
-              </a:rPr>
-              <a:t>Project 2  ·  Computer Vision  ·  Prof. Irene Amerini</a:t>
-            </a:r>
-            <a:endParaRPr lang="en-US" sz="1600" dirty="0"/>
+                <a:ea typeface="Calibri"/>
+                <a:cs typeface="Calibri"/>
+              </a:rPr>
+              <a:t>Raynold Mezini</a:t>
+            </a:r>
           </a:p>
         </p:txBody>
       </p:sp>
@@ -2284,7 +2567,7 @@
           <a:bodyPr wrap="square" lIns="0" tIns="0" rIns="0" bIns="0" rtlCol="0" anchor="ctr"/>
           <a:lstStyle/>
           <a:p>
-            <a:pPr indent="0" marL="0">
+            <a:pPr marL="0" indent="0">
               <a:buNone/>
             </a:pPr>
             <a:r>
@@ -2337,7 +2620,7 @@
         </p:nvSpPr>
         <p:spPr>
           <a:xfrm>
-            <a:off x="9144000" y="2514600"/>
+            <a:off x="9144000" y="2468880"/>
             <a:ext cx="2377440" cy="822960"/>
           </a:xfrm>
           <a:prstGeom prst="rect">
@@ -2350,7 +2633,7 @@
           <a:bodyPr wrap="square" lIns="0" tIns="0" rIns="0" bIns="0" rtlCol="0" anchor="ctr"/>
           <a:lstStyle/>
           <a:p>
-            <a:pPr algn="ctr" indent="0" marL="0">
+            <a:pPr marL="0" indent="0" algn="ctr">
               <a:buNone/>
             </a:pPr>
             <a:r>
@@ -2362,7 +2645,7 @@
                 <a:ea typeface="Cambria" pitchFamily="34" charset="-122"/>
                 <a:cs typeface="Cambria" pitchFamily="34" charset="-120"/>
               </a:rPr>
-              <a:t>0.984</a:t>
+              <a:t>0.986</a:t>
             </a:r>
             <a:endParaRPr lang="en-US" sz="4400" dirty="0"/>
           </a:p>
@@ -2376,7 +2659,7 @@
         </p:nvSpPr>
         <p:spPr>
           <a:xfrm>
-            <a:off x="9144000" y="3291840"/>
+            <a:off x="9144000" y="3246120"/>
             <a:ext cx="2377440" cy="274320"/>
           </a:xfrm>
           <a:prstGeom prst="rect">
@@ -2389,7 +2672,7 @@
           <a:bodyPr wrap="square" lIns="0" tIns="0" rIns="0" bIns="0" rtlCol="0" anchor="ctr"/>
           <a:lstStyle/>
           <a:p>
-            <a:pPr algn="ctr" indent="0" marL="0">
+            <a:pPr marL="0" indent="0" algn="ctr">
               <a:buNone/>
             </a:pPr>
             <a:r>
@@ -2415,7 +2698,7 @@
         </p:nvSpPr>
         <p:spPr>
           <a:xfrm>
-            <a:off x="9144000" y="3611880"/>
+            <a:off x="9144000" y="3566160"/>
             <a:ext cx="2377440" cy="274320"/>
           </a:xfrm>
           <a:prstGeom prst="rect">
@@ -2428,7 +2711,7 @@
           <a:bodyPr wrap="square" lIns="0" tIns="0" rIns="0" bIns="0" rtlCol="0" anchor="ctr"/>
           <a:lstStyle/>
           <a:p>
-            <a:pPr algn="ctr" indent="0" marL="0">
+            <a:pPr marL="0" indent="0" algn="ctr">
               <a:buNone/>
             </a:pPr>
             <a:r>
@@ -2462,6 +2745,7 @@
         <a:solidFill>
           <a:srgbClr val="FFFFFF"/>
         </a:solidFill>
+        <a:effectLst/>
       </p:bgPr>
     </p:bg>
     <p:spTree>
@@ -2499,7 +2783,7 @@
           <a:bodyPr wrap="square" lIns="0" tIns="0" rIns="0" bIns="0" rtlCol="0" anchor="ctr"/>
           <a:lstStyle/>
           <a:p>
-            <a:pPr indent="0" marL="0">
+            <a:pPr marL="0" indent="0">
               <a:buNone/>
             </a:pPr>
             <a:r>
@@ -2538,7 +2822,7 @@
           <a:bodyPr wrap="square" lIns="0" tIns="0" rIns="0" bIns="0" rtlCol="0" anchor="ctr"/>
           <a:lstStyle/>
           <a:p>
-            <a:pPr indent="0" marL="0">
+            <a:pPr marL="0" indent="0">
               <a:lnSpc>
                 <a:spcPts val="2400"/>
               </a:lnSpc>
@@ -2600,7 +2884,7 @@
           <a:bodyPr wrap="square" lIns="0" tIns="0" rIns="0" bIns="0" rtlCol="0" anchor="ctr"/>
           <a:lstStyle/>
           <a:p>
-            <a:pPr algn="ctr" indent="0" marL="0">
+            <a:pPr marL="0" indent="0" algn="ctr">
               <a:buNone/>
             </a:pPr>
             <a:r>
@@ -2639,7 +2923,7 @@
           <a:bodyPr wrap="square" lIns="0" tIns="0" rIns="0" bIns="0" rtlCol="0" anchor="ctr"/>
           <a:lstStyle/>
           <a:p>
-            <a:pPr indent="0" marL="0">
+            <a:pPr marL="0" indent="0">
               <a:buNone/>
             </a:pPr>
             <a:r>
@@ -2678,7 +2962,7 @@
           <a:bodyPr wrap="square" lIns="0" tIns="0" rIns="0" bIns="0" rtlCol="0" anchor="ctr"/>
           <a:lstStyle/>
           <a:p>
-            <a:pPr indent="0" marL="0">
+            <a:pPr marL="0" indent="0">
               <a:buNone/>
             </a:pPr>
             <a:r>
@@ -2737,7 +3021,7 @@
           <a:bodyPr wrap="square" lIns="0" tIns="0" rIns="0" bIns="0" rtlCol="0" anchor="ctr"/>
           <a:lstStyle/>
           <a:p>
-            <a:pPr algn="ctr" indent="0" marL="0">
+            <a:pPr marL="0" indent="0" algn="ctr">
               <a:buNone/>
             </a:pPr>
             <a:r>
@@ -2776,7 +3060,7 @@
           <a:bodyPr wrap="square" lIns="0" tIns="0" rIns="0" bIns="0" rtlCol="0" anchor="ctr"/>
           <a:lstStyle/>
           <a:p>
-            <a:pPr indent="0" marL="0">
+            <a:pPr marL="0" indent="0">
               <a:buNone/>
             </a:pPr>
             <a:r>
@@ -2815,7 +3099,7 @@
           <a:bodyPr wrap="square" lIns="0" tIns="0" rIns="0" bIns="0" rtlCol="0" anchor="ctr"/>
           <a:lstStyle/>
           <a:p>
-            <a:pPr indent="0" marL="0">
+            <a:pPr marL="0" indent="0">
               <a:buNone/>
             </a:pPr>
             <a:r>
@@ -2874,7 +3158,7 @@
           <a:bodyPr wrap="square" lIns="0" tIns="0" rIns="0" bIns="0" rtlCol="0" anchor="ctr"/>
           <a:lstStyle/>
           <a:p>
-            <a:pPr algn="ctr" indent="0" marL="0">
+            <a:pPr marL="0" indent="0" algn="ctr">
               <a:buNone/>
             </a:pPr>
             <a:r>
@@ -2913,7 +3197,7 @@
           <a:bodyPr wrap="square" lIns="0" tIns="0" rIns="0" bIns="0" rtlCol="0" anchor="ctr"/>
           <a:lstStyle/>
           <a:p>
-            <a:pPr indent="0" marL="0">
+            <a:pPr marL="0" indent="0">
               <a:buNone/>
             </a:pPr>
             <a:r>
@@ -2952,7 +3236,7 @@
           <a:bodyPr wrap="square" lIns="0" tIns="0" rIns="0" bIns="0" rtlCol="0" anchor="ctr"/>
           <a:lstStyle/>
           <a:p>
-            <a:pPr indent="0" marL="0">
+            <a:pPr marL="0" indent="0">
               <a:buNone/>
             </a:pPr>
             <a:r>
@@ -3018,11 +3302,11 @@
           <a:bodyPr wrap="square" lIns="0" tIns="0" rIns="0" bIns="0" rtlCol="0" anchor="ctr"/>
           <a:lstStyle/>
           <a:p>
-            <a:pPr indent="0" marL="0">
-              <a:buNone/>
-            </a:pPr>
-            <a:r>
-              <a:rPr lang="en-US" sz="1100" b="1" spc="100" kern="0" dirty="0">
+            <a:pPr marL="0" indent="0">
+              <a:buNone/>
+            </a:pPr>
+            <a:r>
+              <a:rPr lang="en-US" sz="1100" b="1" kern="0" spc="100" dirty="0">
                 <a:solidFill>
                   <a:srgbClr val="8A99A8"/>
                 </a:solidFill>
@@ -3057,7 +3341,7 @@
           <a:bodyPr wrap="square" lIns="0" tIns="0" rIns="0" bIns="0" rtlCol="0" anchor="ctr"/>
           <a:lstStyle/>
           <a:p>
-            <a:pPr indent="0" marL="0">
+            <a:pPr marL="0" indent="0">
               <a:buNone/>
             </a:pPr>
             <a:r>
@@ -3096,7 +3380,7 @@
           <a:bodyPr wrap="square" lIns="0" tIns="0" rIns="0" bIns="0" rtlCol="0" anchor="ctr"/>
           <a:lstStyle/>
           <a:p>
-            <a:pPr indent="0" marL="0">
+            <a:pPr marL="0" indent="0">
               <a:lnSpc>
                 <a:spcPts val="1900"/>
               </a:lnSpc>
@@ -3111,12 +3395,12 @@
                 <a:ea typeface="Calibri" pitchFamily="34" charset="-122"/>
                 <a:cs typeface="Calibri" pitchFamily="34" charset="-120"/>
               </a:rPr>
-              <a:t>1,449 indoor RGB-D pairs. Bedrooms, kitchens,</a:t>
+              <a:t>1,449 indoor RGB-D pairs, split 1,159 / 290.</a:t>
             </a:r>
             <a:endParaRPr lang="en-US" sz="1300" dirty="0"/>
           </a:p>
           <a:p>
-            <a:pPr indent="0" marL="0">
+            <a:pPr marL="0" indent="0">
               <a:lnSpc>
                 <a:spcPts val="1900"/>
               </a:lnSpc>
@@ -3131,7 +3415,7 @@
                 <a:ea typeface="Calibri" pitchFamily="34" charset="-122"/>
                 <a:cs typeface="Calibri" pitchFamily="34" charset="-120"/>
               </a:rPr>
-              <a:t>offices. Depths from 0.7 m to 10 m.</a:t>
+              <a:t>Depths from 0.7 m to 10 m.</a:t>
             </a:r>
             <a:endParaRPr lang="en-US" sz="1300" dirty="0"/>
           </a:p>
@@ -3156,12 +3440,7 @@
           <a:solidFill>
             <a:srgbClr val="21295C"/>
           </a:solidFill>
-          <a:ln w="12700">
-            <a:solidFill>
-              <a:srgbClr val="21295C"/>
-            </a:solidFill>
-            <a:prstDash val="solid"/>
-          </a:ln>
+          <a:ln/>
         </p:spPr>
       </p:sp>
       <p:sp>
@@ -3185,11 +3464,11 @@
           <a:bodyPr wrap="square" lIns="0" tIns="0" rIns="0" bIns="0" rtlCol="0" anchor="ctr"/>
           <a:lstStyle/>
           <a:p>
-            <a:pPr indent="0" marL="0">
-              <a:buNone/>
-            </a:pPr>
-            <a:r>
-              <a:rPr lang="en-US" sz="1100" b="1" spc="100" kern="0" dirty="0">
+            <a:pPr marL="0" indent="0">
+              <a:buNone/>
+            </a:pPr>
+            <a:r>
+              <a:rPr lang="en-US" sz="1100" b="1" kern="0" spc="100" dirty="0">
                 <a:solidFill>
                   <a:srgbClr val="8A99A8"/>
                 </a:solidFill>
@@ -3224,7 +3503,7 @@
           <a:bodyPr wrap="square" lIns="0" tIns="0" rIns="0" bIns="0" rtlCol="0" anchor="ctr"/>
           <a:lstStyle/>
           <a:p>
-            <a:pPr indent="0" marL="0">
+            <a:pPr marL="0" indent="0">
               <a:buNone/>
             </a:pPr>
             <a:r>
@@ -3263,7 +3542,7 @@
           <a:bodyPr wrap="square" lIns="0" tIns="0" rIns="0" bIns="0" rtlCol="0" anchor="ctr"/>
           <a:lstStyle/>
           <a:p>
-            <a:pPr indent="0" marL="0">
+            <a:pPr marL="0" indent="0">
               <a:lnSpc>
                 <a:spcPts val="1900"/>
               </a:lnSpc>
@@ -3278,12 +3557,12 @@
                 <a:ea typeface="Calibri" pitchFamily="34" charset="-122"/>
                 <a:cs typeface="Calibri" pitchFamily="34" charset="-120"/>
               </a:rPr>
-              <a:t>800 outdoor driving frames. Roads, sky, traffic.</a:t>
+              <a:t>800 outdoor driving frames, centre-cropped</a:t>
             </a:r>
             <a:endParaRPr lang="en-US" sz="1300" dirty="0"/>
           </a:p>
           <a:p>
-            <a:pPr indent="0" marL="0">
+            <a:pPr marL="0" indent="0">
               <a:lnSpc>
                 <a:spcPts val="1900"/>
               </a:lnSpc>
@@ -3298,7 +3577,7 @@
                 <a:ea typeface="Calibri" pitchFamily="34" charset="-122"/>
                 <a:cs typeface="Calibri" pitchFamily="34" charset="-120"/>
               </a:rPr>
-              <a:t>Distances an order of magnitude larger.</a:t>
+              <a:t>to preserve geometry before resizing.</a:t>
             </a:r>
             <a:endParaRPr lang="en-US" sz="1300" dirty="0"/>
           </a:p>
@@ -3320,6 +3599,7 @@
         <a:solidFill>
           <a:srgbClr val="FFFFFF"/>
         </a:solidFill>
+        <a:effectLst/>
       </p:bgPr>
     </p:bg>
     <p:spTree>
@@ -3357,7 +3637,7 @@
           <a:bodyPr wrap="square" lIns="0" tIns="0" rIns="0" bIns="0" rtlCol="0" anchor="ctr"/>
           <a:lstStyle/>
           <a:p>
-            <a:pPr indent="0" marL="0">
+            <a:pPr marL="0" indent="0">
               <a:buNone/>
             </a:pPr>
             <a:r>
@@ -3396,7 +3676,7 @@
           <a:bodyPr wrap="square" lIns="0" tIns="0" rIns="0" bIns="0" rtlCol="0" anchor="ctr"/>
           <a:lstStyle/>
           <a:p>
-            <a:pPr indent="0" marL="0">
+            <a:pPr marL="0" indent="0">
               <a:buNone/>
             </a:pPr>
             <a:r>
@@ -3462,7 +3742,7 @@
           <a:bodyPr wrap="square" lIns="0" tIns="0" rIns="0" bIns="0" rtlCol="0" anchor="ctr"/>
           <a:lstStyle/>
           <a:p>
-            <a:pPr indent="0" marL="0">
+            <a:pPr marL="0" indent="0">
               <a:buNone/>
             </a:pPr>
             <a:r>
@@ -3501,7 +3781,7 @@
           <a:bodyPr wrap="square" lIns="0" tIns="0" rIns="0" bIns="0" rtlCol="0" anchor="ctr"/>
           <a:lstStyle/>
           <a:p>
-            <a:pPr indent="0" marL="0">
+            <a:pPr marL="0" indent="0">
               <a:buNone/>
             </a:pPr>
             <a:r>
@@ -3528,26 +3808,26 @@
         <p:spPr>
           <a:xfrm>
             <a:off x="914400" y="3200400"/>
-            <a:ext cx="2011680" cy="1188720"/>
-          </a:xfrm>
-          <a:prstGeom prst="rect">
-            <a:avLst/>
-          </a:prstGeom>
-          <a:noFill/>
-          <a:ln/>
-        </p:spPr>
-        <p:txBody>
-          <a:bodyPr wrap="square" lIns="0" tIns="0" rIns="0" bIns="0" rtlCol="0" anchor="ctr"/>
-          <a:lstStyle/>
-          <a:p>
-            <a:pPr indent="0" marL="0">
+            <a:ext cx="2011680" cy="1280160"/>
+          </a:xfrm>
+          <a:prstGeom prst="rect">
+            <a:avLst/>
+          </a:prstGeom>
+          <a:noFill/>
+          <a:ln/>
+        </p:spPr>
+        <p:txBody>
+          <a:bodyPr wrap="square" lIns="0" tIns="0" rIns="0" bIns="0" rtlCol="0" anchor="ctr"/>
+          <a:lstStyle/>
+          <a:p>
+            <a:pPr marL="0" indent="0">
               <a:lnSpc>
-                <a:spcPts val="1700"/>
+                <a:spcPts val="1500"/>
               </a:lnSpc>
               <a:buNone/>
             </a:pPr>
             <a:r>
-              <a:rPr lang="en-US" sz="1200" dirty="0">
+              <a:rPr lang="en-US" sz="1100" dirty="0">
                 <a:solidFill>
                   <a:srgbClr val="6B7885"/>
                 </a:solidFill>
@@ -3555,9 +3835,9 @@
                 <a:ea typeface="Calibri" pitchFamily="34" charset="-122"/>
                 <a:cs typeface="Calibri" pitchFamily="34" charset="-120"/>
               </a:rPr>
-              <a:t>ResNet18 encoder + upsampling decoder on NYU v2. L1 loss in log-depth space.</a:t>
-            </a:r>
-            <a:endParaRPr lang="en-US" sz="1200" dirty="0"/>
+              <a:t>ResNet encoder + upsampling decoder on NYU v2. L1 loss in log-depth space, flip augmentation, best-epoch checkpointing.</a:t>
+            </a:r>
+            <a:endParaRPr lang="en-US" sz="1100" dirty="0"/>
           </a:p>
         </p:txBody>
       </p:sp>
@@ -3609,7 +3889,7 @@
           <a:bodyPr wrap="square" lIns="0" tIns="0" rIns="0" bIns="0" rtlCol="0" anchor="ctr"/>
           <a:lstStyle/>
           <a:p>
-            <a:pPr indent="0" marL="0">
+            <a:pPr marL="0" indent="0">
               <a:buNone/>
             </a:pPr>
             <a:r>
@@ -3648,7 +3928,7 @@
           <a:bodyPr wrap="square" lIns="0" tIns="0" rIns="0" bIns="0" rtlCol="0" anchor="ctr"/>
           <a:lstStyle/>
           <a:p>
-            <a:pPr indent="0" marL="0">
+            <a:pPr marL="0" indent="0">
               <a:buNone/>
             </a:pPr>
             <a:r>
@@ -3675,26 +3955,26 @@
         <p:spPr>
           <a:xfrm>
             <a:off x="3703320" y="3200400"/>
-            <a:ext cx="2011680" cy="1188720"/>
-          </a:xfrm>
-          <a:prstGeom prst="rect">
-            <a:avLst/>
-          </a:prstGeom>
-          <a:noFill/>
-          <a:ln/>
-        </p:spPr>
-        <p:txBody>
-          <a:bodyPr wrap="square" lIns="0" tIns="0" rIns="0" bIns="0" rtlCol="0" anchor="ctr"/>
-          <a:lstStyle/>
-          <a:p>
-            <a:pPr indent="0" marL="0">
+            <a:ext cx="2011680" cy="1280160"/>
+          </a:xfrm>
+          <a:prstGeom prst="rect">
+            <a:avLst/>
+          </a:prstGeom>
+          <a:noFill/>
+          <a:ln/>
+        </p:spPr>
+        <p:txBody>
+          <a:bodyPr wrap="square" lIns="0" tIns="0" rIns="0" bIns="0" rtlCol="0" anchor="ctr"/>
+          <a:lstStyle/>
+          <a:p>
+            <a:pPr marL="0" indent="0">
               <a:lnSpc>
-                <a:spcPts val="1700"/>
+                <a:spcPts val="1500"/>
               </a:lnSpc>
               <a:buNone/>
             </a:pPr>
             <a:r>
-              <a:rPr lang="en-US" sz="1200" dirty="0">
+              <a:rPr lang="en-US" sz="1100" dirty="0">
                 <a:solidFill>
                   <a:srgbClr val="6B7885"/>
                 </a:solidFill>
@@ -3702,9 +3982,9 @@
                 <a:ea typeface="Calibri" pitchFamily="34" charset="-122"/>
                 <a:cs typeface="Calibri" pitchFamily="34" charset="-120"/>
               </a:rPr>
-              <a:t>Forward hooks on all four residual stages capture activations during inference.</a:t>
-            </a:r>
-            <a:endParaRPr lang="en-US" sz="1200" dirty="0"/>
+              <a:t>Forward hooks on all four residual stages capture activations during a single inference pass.</a:t>
+            </a:r>
+            <a:endParaRPr lang="en-US" sz="1100" dirty="0"/>
           </a:p>
         </p:txBody>
       </p:sp>
@@ -3756,7 +4036,7 @@
           <a:bodyPr wrap="square" lIns="0" tIns="0" rIns="0" bIns="0" rtlCol="0" anchor="ctr"/>
           <a:lstStyle/>
           <a:p>
-            <a:pPr indent="0" marL="0">
+            <a:pPr marL="0" indent="0">
               <a:buNone/>
             </a:pPr>
             <a:r>
@@ -3795,7 +4075,7 @@
           <a:bodyPr wrap="square" lIns="0" tIns="0" rIns="0" bIns="0" rtlCol="0" anchor="ctr"/>
           <a:lstStyle/>
           <a:p>
-            <a:pPr indent="0" marL="0">
+            <a:pPr marL="0" indent="0">
               <a:buNone/>
             </a:pPr>
             <a:r>
@@ -3822,26 +4102,26 @@
         <p:spPr>
           <a:xfrm>
             <a:off x="6492240" y="3200400"/>
-            <a:ext cx="2011680" cy="1188720"/>
-          </a:xfrm>
-          <a:prstGeom prst="rect">
-            <a:avLst/>
-          </a:prstGeom>
-          <a:noFill/>
-          <a:ln/>
-        </p:spPr>
-        <p:txBody>
-          <a:bodyPr wrap="square" lIns="0" tIns="0" rIns="0" bIns="0" rtlCol="0" anchor="ctr"/>
-          <a:lstStyle/>
-          <a:p>
-            <a:pPr indent="0" marL="0">
+            <a:ext cx="2011680" cy="1280160"/>
+          </a:xfrm>
+          <a:prstGeom prst="rect">
+            <a:avLst/>
+          </a:prstGeom>
+          <a:noFill/>
+          <a:ln/>
+        </p:spPr>
+        <p:txBody>
+          <a:bodyPr wrap="square" lIns="0" tIns="0" rIns="0" bIns="0" rtlCol="0" anchor="ctr"/>
+          <a:lstStyle/>
+          <a:p>
+            <a:pPr marL="0" indent="0">
               <a:lnSpc>
-                <a:spcPts val="1700"/>
+                <a:spcPts val="1500"/>
               </a:lnSpc>
               <a:buNone/>
             </a:pPr>
             <a:r>
-              <a:rPr lang="en-US" sz="1200" dirty="0">
+              <a:rPr lang="en-US" sz="1100" dirty="0">
                 <a:solidFill>
                   <a:srgbClr val="CADCFC"/>
                 </a:solidFill>
@@ -3849,9 +4129,9 @@
                 <a:ea typeface="Calibri" pitchFamily="34" charset="-122"/>
                 <a:cs typeface="Calibri" pitchFamily="34" charset="-120"/>
               </a:rPr>
-              <a:t>Per-channel 95th percentile, then standard deviation across channels.</a:t>
-            </a:r>
-            <a:endParaRPr lang="en-US" sz="1200" dirty="0"/>
+              <a:t>Per-channel 95th percentile, then the standard deviation of those values across channels.</a:t>
+            </a:r>
+            <a:endParaRPr lang="en-US" sz="1100" dirty="0"/>
           </a:p>
         </p:txBody>
       </p:sp>
@@ -3903,7 +4183,7 @@
           <a:bodyPr wrap="square" lIns="0" tIns="0" rIns="0" bIns="0" rtlCol="0" anchor="ctr"/>
           <a:lstStyle/>
           <a:p>
-            <a:pPr indent="0" marL="0">
+            <a:pPr marL="0" indent="0">
               <a:buNone/>
             </a:pPr>
             <a:r>
@@ -3942,7 +4222,7 @@
           <a:bodyPr wrap="square" lIns="0" tIns="0" rIns="0" bIns="0" rtlCol="0" anchor="ctr"/>
           <a:lstStyle/>
           <a:p>
-            <a:pPr indent="0" marL="0">
+            <a:pPr marL="0" indent="0">
               <a:buNone/>
             </a:pPr>
             <a:r>
@@ -3969,26 +4249,26 @@
         <p:spPr>
           <a:xfrm>
             <a:off x="9281160" y="3200400"/>
-            <a:ext cx="2011680" cy="1188720"/>
-          </a:xfrm>
-          <a:prstGeom prst="rect">
-            <a:avLst/>
-          </a:prstGeom>
-          <a:noFill/>
-          <a:ln/>
-        </p:spPr>
-        <p:txBody>
-          <a:bodyPr wrap="square" lIns="0" tIns="0" rIns="0" bIns="0" rtlCol="0" anchor="ctr"/>
-          <a:lstStyle/>
-          <a:p>
-            <a:pPr indent="0" marL="0">
+            <a:ext cx="2011680" cy="1280160"/>
+          </a:xfrm>
+          <a:prstGeom prst="rect">
+            <a:avLst/>
+          </a:prstGeom>
+          <a:noFill/>
+          <a:ln/>
+        </p:spPr>
+        <p:txBody>
+          <a:bodyPr wrap="square" lIns="0" tIns="0" rIns="0" bIns="0" rtlCol="0" anchor="ctr"/>
+          <a:lstStyle/>
+          <a:p>
+            <a:pPr marL="0" indent="0">
               <a:lnSpc>
-                <a:spcPts val="1700"/>
+                <a:spcPts val="1500"/>
               </a:lnSpc>
               <a:buNone/>
             </a:pPr>
             <a:r>
-              <a:rPr lang="en-US" sz="1200" dirty="0">
+              <a:rPr lang="en-US" sz="1100" dirty="0">
                 <a:solidFill>
                   <a:srgbClr val="6B7885"/>
                 </a:solidFill>
@@ -3996,9 +4276,9 @@
                 <a:ea typeface="Calibri" pitchFamily="34" charset="-122"/>
                 <a:cs typeface="Calibri" pitchFamily="34" charset="-120"/>
               </a:rPr>
-              <a:t>Standardise on ID statistics, average layers, measure AUROC and FPR95.</a:t>
-            </a:r>
-            <a:endParaRPr lang="en-US" sz="1200" dirty="0"/>
+              <a:t>Standardise on ID statistics, average the layers, measure AUROC and FPR95.</a:t>
+            </a:r>
+            <a:endParaRPr lang="en-US" sz="1100" dirty="0"/>
           </a:p>
         </p:txBody>
       </p:sp>
@@ -4050,7 +4330,7 @@
           <a:bodyPr wrap="square" lIns="0" tIns="0" rIns="0" bIns="0" rtlCol="0" anchor="ctr"/>
           <a:lstStyle/>
           <a:p>
-            <a:pPr indent="0" marL="0">
+            <a:pPr marL="0" indent="0">
               <a:buNone/>
             </a:pPr>
             <a:r>
@@ -4084,6 +4364,7 @@
         <a:solidFill>
           <a:srgbClr val="FFFFFF"/>
         </a:solidFill>
+        <a:effectLst/>
       </p:bgPr>
     </p:bg>
     <p:spTree>
@@ -4121,7 +4402,7 @@
           <a:bodyPr wrap="square" lIns="0" tIns="0" rIns="0" bIns="0" rtlCol="0" anchor="ctr"/>
           <a:lstStyle/>
           <a:p>
-            <a:pPr indent="0" marL="0">
+            <a:pPr marL="0" indent="0">
               <a:buNone/>
             </a:pPr>
             <a:r>
@@ -4148,19 +4429,19 @@
         <p:spPr>
           <a:xfrm>
             <a:off x="640080" y="1143000"/>
-            <a:ext cx="10058400" cy="320040"/>
-          </a:xfrm>
-          <a:prstGeom prst="rect">
-            <a:avLst/>
-          </a:prstGeom>
-          <a:noFill/>
-          <a:ln/>
-        </p:spPr>
-        <p:txBody>
-          <a:bodyPr wrap="square" lIns="0" tIns="0" rIns="0" bIns="0" rtlCol="0" anchor="ctr"/>
-          <a:lstStyle/>
-          <a:p>
-            <a:pPr indent="0" marL="0">
+            <a:ext cx="10515600" cy="320040"/>
+          </a:xfrm>
+          <a:prstGeom prst="rect">
+            <a:avLst/>
+          </a:prstGeom>
+          <a:noFill/>
+          <a:ln/>
+        </p:spPr>
+        <p:txBody>
+          <a:bodyPr wrap="square" lIns="0" tIns="0" rIns="0" bIns="0" rtlCol="0" anchor="ctr"/>
+          <a:lstStyle/>
+          <a:p>
+            <a:pPr marL="0" indent="0">
               <a:buNone/>
             </a:pPr>
             <a:r>
@@ -4172,7 +4453,7 @@
                 <a:ea typeface="Calibri" pitchFamily="34" charset="-122"/>
                 <a:cs typeface="Calibri" pitchFamily="34" charset="-120"/>
               </a:rPr>
-              <a:t>Lightweight convolutional encoder–decoder, 224 × 304 input.</a:t>
+              <a:t>Lightweight convolutional encoder–decoder, 224 × 304 input. Two backbones trained for comparison.</a:t>
             </a:r>
             <a:endParaRPr lang="en-US" sz="1500" dirty="0"/>
           </a:p>
@@ -4226,11 +4507,11 @@
           <a:bodyPr wrap="square" lIns="0" tIns="0" rIns="0" bIns="0" rtlCol="0" anchor="ctr"/>
           <a:lstStyle/>
           <a:p>
-            <a:pPr indent="0" marL="0">
-              <a:buNone/>
-            </a:pPr>
-            <a:r>
-              <a:rPr lang="en-US" sz="1100" b="1" spc="100" kern="0" dirty="0">
+            <a:pPr marL="0" indent="0">
+              <a:buNone/>
+            </a:pPr>
+            <a:r>
+              <a:rPr lang="en-US" sz="1100" b="1" kern="0" spc="100" dirty="0">
                 <a:solidFill>
                   <a:srgbClr val="8A99A8"/>
                 </a:solidFill>
@@ -4265,7 +4546,7 @@
           <a:bodyPr wrap="square" lIns="0" tIns="0" rIns="0" bIns="0" rtlCol="0" anchor="ctr"/>
           <a:lstStyle/>
           <a:p>
-            <a:pPr indent="0" marL="0">
+            <a:pPr marL="0" indent="0">
               <a:buNone/>
             </a:pPr>
             <a:r>
@@ -4277,7 +4558,7 @@
                 <a:ea typeface="Cambria" pitchFamily="34" charset="-122"/>
                 <a:cs typeface="Cambria" pitchFamily="34" charset="-120"/>
               </a:rPr>
-              <a:t>ResNet18, ImageNet pretrained</a:t>
+              <a:t>ResNet18 / ResNet34</a:t>
             </a:r>
             <a:endParaRPr lang="en-US" sz="2000" dirty="0"/>
           </a:p>
@@ -4320,7 +4601,7 @@
                 <a:ea typeface="Calibri" pitchFamily="34" charset="-122"/>
                 <a:cs typeface="Calibri" pitchFamily="34" charset="-120"/>
               </a:rPr>
-              <a:t>Classification head removed (avgpool, fc)</a:t>
+              <a:t>ImageNet pretrained, classification head removed</a:t>
             </a:r>
             <a:endParaRPr lang="en-US" sz="1300" dirty="0"/>
           </a:p>
@@ -4416,11 +4697,11 @@
           <a:bodyPr wrap="square" lIns="0" tIns="0" rIns="0" bIns="0" rtlCol="0" anchor="ctr"/>
           <a:lstStyle/>
           <a:p>
-            <a:pPr indent="0" marL="0">
-              <a:buNone/>
-            </a:pPr>
-            <a:r>
-              <a:rPr lang="en-US" sz="1100" b="1" spc="100" kern="0" dirty="0">
+            <a:pPr marL="0" indent="0">
+              <a:buNone/>
+            </a:pPr>
+            <a:r>
+              <a:rPr lang="en-US" sz="1100" b="1" kern="0" spc="100" dirty="0">
                 <a:solidFill>
                   <a:srgbClr val="8A99A8"/>
                 </a:solidFill>
@@ -4455,7 +4736,7 @@
           <a:bodyPr wrap="square" lIns="0" tIns="0" rIns="0" bIns="0" rtlCol="0" anchor="ctr"/>
           <a:lstStyle/>
           <a:p>
-            <a:pPr indent="0" marL="0">
+            <a:pPr marL="0" indent="0">
               <a:buNone/>
             </a:pPr>
             <a:r>
@@ -4599,7 +4880,7 @@
           <a:bodyPr wrap="square" lIns="0" tIns="0" rIns="0" bIns="0" rtlCol="0" anchor="ctr"/>
           <a:lstStyle/>
           <a:p>
-            <a:pPr indent="0" marL="0">
+            <a:pPr marL="0" indent="0">
               <a:buNone/>
             </a:pPr>
             <a:r>
@@ -4638,7 +4919,7 @@
           <a:bodyPr wrap="square" lIns="0" tIns="0" rIns="0" bIns="0" rtlCol="0" anchor="ctr"/>
           <a:lstStyle/>
           <a:p>
-            <a:pPr indent="0" marL="0">
+            <a:pPr marL="0" indent="0">
               <a:lnSpc>
                 <a:spcPts val="1500"/>
               </a:lnSpc>
@@ -4700,7 +4981,7 @@
           <a:bodyPr wrap="square" lIns="0" tIns="0" rIns="0" bIns="0" rtlCol="0" anchor="ctr"/>
           <a:lstStyle/>
           <a:p>
-            <a:pPr indent="0" marL="0">
+            <a:pPr marL="0" indent="0">
               <a:buNone/>
             </a:pPr>
             <a:r>
@@ -4739,7 +5020,7 @@
           <a:bodyPr wrap="square" lIns="0" tIns="0" rIns="0" bIns="0" rtlCol="0" anchor="ctr"/>
           <a:lstStyle/>
           <a:p>
-            <a:pPr indent="0" marL="0">
+            <a:pPr marL="0" indent="0">
               <a:lnSpc>
                 <a:spcPts val="1500"/>
               </a:lnSpc>
@@ -4801,7 +5082,7 @@
           <a:bodyPr wrap="square" lIns="0" tIns="0" rIns="0" bIns="0" rtlCol="0" anchor="ctr"/>
           <a:lstStyle/>
           <a:p>
-            <a:pPr indent="0" marL="0">
+            <a:pPr marL="0" indent="0">
               <a:buNone/>
             </a:pPr>
             <a:r>
@@ -4840,7 +5121,7 @@
           <a:bodyPr wrap="square" lIns="0" tIns="0" rIns="0" bIns="0" rtlCol="0" anchor="ctr"/>
           <a:lstStyle/>
           <a:p>
-            <a:pPr indent="0" marL="0">
+            <a:pPr marL="0" indent="0">
               <a:lnSpc>
                 <a:spcPts val="1500"/>
               </a:lnSpc>
@@ -4877,6 +5158,7 @@
         <a:solidFill>
           <a:srgbClr val="FFFFFF"/>
         </a:solidFill>
+        <a:effectLst/>
       </p:bgPr>
     </p:bg>
     <p:spTree>
@@ -4914,7 +5196,7 @@
           <a:bodyPr wrap="square" lIns="0" tIns="0" rIns="0" bIns="0" rtlCol="0" anchor="ctr"/>
           <a:lstStyle/>
           <a:p>
-            <a:pPr indent="0" marL="0">
+            <a:pPr marL="0" indent="0">
               <a:buNone/>
             </a:pPr>
             <a:r>
@@ -4941,19 +5223,19 @@
         <p:spPr>
           <a:xfrm>
             <a:off x="640080" y="1143000"/>
-            <a:ext cx="10058400" cy="320040"/>
-          </a:xfrm>
-          <a:prstGeom prst="rect">
-            <a:avLst/>
-          </a:prstGeom>
-          <a:noFill/>
-          <a:ln/>
-        </p:spPr>
-        <p:txBody>
-          <a:bodyPr wrap="square" lIns="0" tIns="0" rIns="0" bIns="0" rtlCol="0" anchor="ctr"/>
-          <a:lstStyle/>
-          <a:p>
-            <a:pPr indent="0" marL="0">
+            <a:ext cx="10515600" cy="320040"/>
+          </a:xfrm>
+          <a:prstGeom prst="rect">
+            <a:avLst/>
+          </a:prstGeom>
+          <a:noFill/>
+          <a:ln/>
+        </p:spPr>
+        <p:txBody>
+          <a:bodyPr wrap="square" lIns="0" tIns="0" rIns="0" bIns="0" rtlCol="0" anchor="ctr"/>
+          <a:lstStyle/>
+          <a:p>
+            <a:pPr marL="0" indent="0">
               <a:buNone/>
             </a:pPr>
             <a:r>
@@ -4965,7 +5247,7 @@
                 <a:ea typeface="Calibri" pitchFamily="34" charset="-122"/>
                 <a:cs typeface="Calibri" pitchFamily="34" charset="-120"/>
               </a:rPr>
-              <a:t>NYU v2 validation split, 290 held-out images, 40 epochs, AdamW at 1e-4.</a:t>
+              <a:t>NYU v2 validation split, 290 held-out images. 40 epochs, AdamW at 1e-4, weight decay 0.05.</a:t>
             </a:r>
             <a:endParaRPr lang="en-US" sz="1500" dirty="0"/>
           </a:p>
@@ -4980,15 +5262,13 @@
         <p:spPr>
           <a:xfrm>
             <a:off x="640080" y="1828800"/>
-            <a:ext cx="2377440" cy="1737360"/>
-          </a:xfrm>
-          <a:prstGeom prst="roundRect">
-            <a:avLst>
-              <a:gd name="adj" fmla="val 5263"/>
-            </a:avLst>
+            <a:ext cx="4846320" cy="502920"/>
+          </a:xfrm>
+          <a:prstGeom prst="rect">
+            <a:avLst/>
           </a:prstGeom>
           <a:solidFill>
-            <a:srgbClr val="065A82"/>
+            <a:srgbClr val="21295C"/>
           </a:solidFill>
           <a:ln/>
         </p:spPr>
@@ -5001,65 +5281,132 @@
         </p:nvSpPr>
         <p:spPr>
           <a:xfrm>
-            <a:off x="640080" y="2148840"/>
-            <a:ext cx="2377440" cy="731520"/>
-          </a:xfrm>
-          <a:prstGeom prst="rect">
-            <a:avLst/>
-          </a:prstGeom>
-          <a:noFill/>
-          <a:ln/>
-        </p:spPr>
-        <p:txBody>
-          <a:bodyPr wrap="square" lIns="0" tIns="0" rIns="0" bIns="0" rtlCol="0" anchor="ctr"/>
-          <a:lstStyle/>
-          <a:p>
-            <a:pPr algn="ctr" indent="0" marL="0">
-              <a:buNone/>
-            </a:pPr>
-            <a:r>
-              <a:rPr lang="en-US" sz="4000" b="1" dirty="0">
+            <a:off x="822960" y="1828800"/>
+            <a:ext cx="1828800" cy="502920"/>
+          </a:xfrm>
+          <a:prstGeom prst="rect">
+            <a:avLst/>
+          </a:prstGeom>
+          <a:noFill/>
+          <a:ln/>
+        </p:spPr>
+        <p:txBody>
+          <a:bodyPr wrap="square" lIns="0" tIns="0" rIns="0" bIns="0" rtlCol="0" anchor="ctr"/>
+          <a:lstStyle/>
+          <a:p>
+            <a:pPr marL="0" indent="0">
+              <a:buNone/>
+            </a:pPr>
+            <a:endParaRPr lang="en-US" sz="1400" dirty="0"/>
+          </a:p>
+        </p:txBody>
+      </p:sp>
+      <p:sp>
+        <p:nvSpPr>
+          <p:cNvPr id="6" name="Text 4"/>
+          <p:cNvSpPr txBox="1"/>
+          <p:nvPr/>
+        </p:nvSpPr>
+        <p:spPr>
+          <a:xfrm>
+            <a:off x="2651760" y="1828800"/>
+            <a:ext cx="1371600" cy="502920"/>
+          </a:xfrm>
+          <a:prstGeom prst="rect">
+            <a:avLst/>
+          </a:prstGeom>
+          <a:noFill/>
+          <a:ln/>
+        </p:spPr>
+        <p:txBody>
+          <a:bodyPr wrap="square" lIns="0" tIns="0" rIns="0" bIns="0" rtlCol="0" anchor="ctr"/>
+          <a:lstStyle/>
+          <a:p>
+            <a:pPr marL="0" indent="0" algn="ctr">
+              <a:buNone/>
+            </a:pPr>
+            <a:r>
+              <a:rPr lang="en-US" sz="1400" b="1" dirty="0">
                 <a:solidFill>
                   <a:srgbClr val="FFFFFF"/>
                 </a:solidFill>
-                <a:latin typeface="Cambria" pitchFamily="34" charset="0"/>
-                <a:ea typeface="Cambria" pitchFamily="34" charset="-122"/>
-                <a:cs typeface="Cambria" pitchFamily="34" charset="-120"/>
-              </a:rPr>
-              <a:t>0.698</a:t>
-            </a:r>
-            <a:endParaRPr lang="en-US" sz="4000" dirty="0"/>
-          </a:p>
-        </p:txBody>
-      </p:sp>
-      <p:sp>
-        <p:nvSpPr>
-          <p:cNvPr id="6" name="Text 4"/>
-          <p:cNvSpPr txBox="1"/>
-          <p:nvPr/>
-        </p:nvSpPr>
-        <p:spPr>
-          <a:xfrm>
-            <a:off x="640080" y="2926080"/>
-            <a:ext cx="2377440" cy="320040"/>
-          </a:xfrm>
-          <a:prstGeom prst="rect">
-            <a:avLst/>
-          </a:prstGeom>
-          <a:noFill/>
-          <a:ln/>
-        </p:spPr>
-        <p:txBody>
-          <a:bodyPr wrap="square" lIns="0" tIns="0" rIns="0" bIns="0" rtlCol="0" anchor="ctr"/>
-          <a:lstStyle/>
-          <a:p>
-            <a:pPr algn="ctr" indent="0" marL="0">
+                <a:latin typeface="Calibri" pitchFamily="34" charset="0"/>
+                <a:ea typeface="Calibri" pitchFamily="34" charset="-122"/>
+                <a:cs typeface="Calibri" pitchFamily="34" charset="-120"/>
+              </a:rPr>
+              <a:t>ResNet18</a:t>
+            </a:r>
+            <a:endParaRPr lang="en-US" sz="1400" dirty="0"/>
+          </a:p>
+        </p:txBody>
+      </p:sp>
+      <p:sp>
+        <p:nvSpPr>
+          <p:cNvPr id="7" name="Text 5"/>
+          <p:cNvSpPr txBox="1"/>
+          <p:nvPr/>
+        </p:nvSpPr>
+        <p:spPr>
+          <a:xfrm>
+            <a:off x="4023360" y="1828800"/>
+            <a:ext cx="1371600" cy="502920"/>
+          </a:xfrm>
+          <a:prstGeom prst="rect">
+            <a:avLst/>
+          </a:prstGeom>
+          <a:noFill/>
+          <a:ln/>
+        </p:spPr>
+        <p:txBody>
+          <a:bodyPr wrap="square" lIns="0" tIns="0" rIns="0" bIns="0" rtlCol="0" anchor="ctr"/>
+          <a:lstStyle/>
+          <a:p>
+            <a:pPr marL="0" indent="0" algn="ctr">
+              <a:buNone/>
+            </a:pPr>
+            <a:r>
+              <a:rPr lang="en-US" sz="1400" b="1" dirty="0">
+                <a:solidFill>
+                  <a:srgbClr val="FFFFFF"/>
+                </a:solidFill>
+                <a:latin typeface="Calibri" pitchFamily="34" charset="0"/>
+                <a:ea typeface="Calibri" pitchFamily="34" charset="-122"/>
+                <a:cs typeface="Calibri" pitchFamily="34" charset="-120"/>
+              </a:rPr>
+              <a:t>ResNet34</a:t>
+            </a:r>
+            <a:endParaRPr lang="en-US" sz="1400" dirty="0"/>
+          </a:p>
+        </p:txBody>
+      </p:sp>
+      <p:sp>
+        <p:nvSpPr>
+          <p:cNvPr id="8" name="Text 6"/>
+          <p:cNvSpPr txBox="1"/>
+          <p:nvPr/>
+        </p:nvSpPr>
+        <p:spPr>
+          <a:xfrm>
+            <a:off x="822960" y="2331720"/>
+            <a:ext cx="1828800" cy="502920"/>
+          </a:xfrm>
+          <a:prstGeom prst="rect">
+            <a:avLst/>
+          </a:prstGeom>
+          <a:noFill/>
+          <a:ln/>
+        </p:spPr>
+        <p:txBody>
+          <a:bodyPr wrap="square" lIns="0" tIns="0" rIns="0" bIns="0" rtlCol="0" anchor="ctr"/>
+          <a:lstStyle/>
+          <a:p>
+            <a:pPr marL="0" indent="0">
               <a:buNone/>
             </a:pPr>
             <a:r>
               <a:rPr lang="en-US" sz="1400" dirty="0">
                 <a:solidFill>
-                  <a:srgbClr val="CADCFC"/>
+                  <a:srgbClr val="21295C"/>
                 </a:solidFill>
                 <a:latin typeface="Calibri" pitchFamily="34" charset="0"/>
                 <a:ea typeface="Calibri" pitchFamily="34" charset="-122"/>
@@ -5073,99 +5420,585 @@
       </p:sp>
       <p:sp>
         <p:nvSpPr>
-          <p:cNvPr id="7" name="Shape 5"/>
+          <p:cNvPr id="9" name="Text 7"/>
+          <p:cNvSpPr txBox="1"/>
+          <p:nvPr/>
+        </p:nvSpPr>
+        <p:spPr>
+          <a:xfrm>
+            <a:off x="2651760" y="2331720"/>
+            <a:ext cx="1371600" cy="502920"/>
+          </a:xfrm>
+          <a:prstGeom prst="rect">
+            <a:avLst/>
+          </a:prstGeom>
+          <a:noFill/>
+          <a:ln/>
+        </p:spPr>
+        <p:txBody>
+          <a:bodyPr wrap="square" lIns="0" tIns="0" rIns="0" bIns="0" rtlCol="0" anchor="ctr"/>
+          <a:lstStyle/>
+          <a:p>
+            <a:pPr marL="0" indent="0" algn="ctr">
+              <a:buNone/>
+            </a:pPr>
+            <a:r>
+              <a:rPr lang="en-US" sz="1400" dirty="0">
+                <a:solidFill>
+                  <a:srgbClr val="3A4652"/>
+                </a:solidFill>
+                <a:latin typeface="Calibri" pitchFamily="34" charset="0"/>
+                <a:ea typeface="Calibri" pitchFamily="34" charset="-122"/>
+                <a:cs typeface="Calibri" pitchFamily="34" charset="-120"/>
+              </a:rPr>
+              <a:t>0.691</a:t>
+            </a:r>
+            <a:endParaRPr lang="en-US" sz="1400" dirty="0"/>
+          </a:p>
+        </p:txBody>
+      </p:sp>
+      <p:sp>
+        <p:nvSpPr>
+          <p:cNvPr id="10" name="Text 8"/>
+          <p:cNvSpPr txBox="1"/>
+          <p:nvPr/>
+        </p:nvSpPr>
+        <p:spPr>
+          <a:xfrm>
+            <a:off x="4023360" y="2331720"/>
+            <a:ext cx="1371600" cy="502920"/>
+          </a:xfrm>
+          <a:prstGeom prst="rect">
+            <a:avLst/>
+          </a:prstGeom>
+          <a:noFill/>
+          <a:ln/>
+        </p:spPr>
+        <p:txBody>
+          <a:bodyPr wrap="square" lIns="0" tIns="0" rIns="0" bIns="0" rtlCol="0" anchor="ctr"/>
+          <a:lstStyle/>
+          <a:p>
+            <a:pPr marL="0" indent="0" algn="ctr">
+              <a:buNone/>
+            </a:pPr>
+            <a:r>
+              <a:rPr lang="en-US" sz="1400" b="1" dirty="0">
+                <a:solidFill>
+                  <a:srgbClr val="065A82"/>
+                </a:solidFill>
+                <a:latin typeface="Calibri" pitchFamily="34" charset="0"/>
+                <a:ea typeface="Calibri" pitchFamily="34" charset="-122"/>
+                <a:cs typeface="Calibri" pitchFamily="34" charset="-120"/>
+              </a:rPr>
+              <a:t>0.597</a:t>
+            </a:r>
+            <a:endParaRPr lang="en-US" sz="1400" dirty="0"/>
+          </a:p>
+        </p:txBody>
+      </p:sp>
+      <p:sp>
+        <p:nvSpPr>
+          <p:cNvPr id="11" name="Shape 9"/>
           <p:cNvSpPr/>
           <p:nvPr/>
         </p:nvSpPr>
         <p:spPr>
           <a:xfrm>
-            <a:off x="3291840" y="1828800"/>
-            <a:ext cx="2377440" cy="1737360"/>
-          </a:xfrm>
-          <a:prstGeom prst="roundRect">
-            <a:avLst>
-              <a:gd name="adj" fmla="val 5263"/>
-            </a:avLst>
+            <a:off x="640080" y="2834640"/>
+            <a:ext cx="4846320" cy="502920"/>
+          </a:xfrm>
+          <a:prstGeom prst="rect">
+            <a:avLst/>
           </a:prstGeom>
           <a:solidFill>
-            <a:srgbClr val="1C7293"/>
+            <a:srgbClr val="F4F7FA"/>
           </a:solidFill>
           <a:ln/>
         </p:spPr>
       </p:sp>
       <p:sp>
         <p:nvSpPr>
-          <p:cNvPr id="8" name="Text 6"/>
-          <p:cNvSpPr txBox="1"/>
-          <p:nvPr/>
-        </p:nvSpPr>
-        <p:spPr>
-          <a:xfrm>
-            <a:off x="3291840" y="2148840"/>
-            <a:ext cx="2377440" cy="731520"/>
-          </a:xfrm>
-          <a:prstGeom prst="rect">
-            <a:avLst/>
-          </a:prstGeom>
-          <a:noFill/>
-          <a:ln/>
-        </p:spPr>
-        <p:txBody>
-          <a:bodyPr wrap="square" lIns="0" tIns="0" rIns="0" bIns="0" rtlCol="0" anchor="ctr"/>
-          <a:lstStyle/>
-          <a:p>
-            <a:pPr algn="ctr" indent="0" marL="0">
-              <a:buNone/>
-            </a:pPr>
-            <a:r>
-              <a:rPr lang="en-US" sz="4000" b="1" dirty="0">
-                <a:solidFill>
-                  <a:srgbClr val="FFFFFF"/>
-                </a:solidFill>
-                <a:latin typeface="Cambria" pitchFamily="34" charset="0"/>
-                <a:ea typeface="Cambria" pitchFamily="34" charset="-122"/>
-                <a:cs typeface="Cambria" pitchFamily="34" charset="-120"/>
-              </a:rPr>
-              <a:t>0.205</a:t>
-            </a:r>
-            <a:endParaRPr lang="en-US" sz="4000" dirty="0"/>
-          </a:p>
-        </p:txBody>
-      </p:sp>
-      <p:sp>
-        <p:nvSpPr>
-          <p:cNvPr id="9" name="Text 7"/>
-          <p:cNvSpPr txBox="1"/>
-          <p:nvPr/>
-        </p:nvSpPr>
-        <p:spPr>
-          <a:xfrm>
-            <a:off x="3291840" y="2926080"/>
-            <a:ext cx="2377440" cy="320040"/>
-          </a:xfrm>
-          <a:prstGeom prst="rect">
-            <a:avLst/>
-          </a:prstGeom>
-          <a:noFill/>
-          <a:ln/>
-        </p:spPr>
-        <p:txBody>
-          <a:bodyPr wrap="square" lIns="0" tIns="0" rIns="0" bIns="0" rtlCol="0" anchor="ctr"/>
-          <a:lstStyle/>
-          <a:p>
-            <a:pPr algn="ctr" indent="0" marL="0">
+          <p:cNvPr id="12" name="Text 10"/>
+          <p:cNvSpPr txBox="1"/>
+          <p:nvPr/>
+        </p:nvSpPr>
+        <p:spPr>
+          <a:xfrm>
+            <a:off x="822960" y="2834640"/>
+            <a:ext cx="1828800" cy="502920"/>
+          </a:xfrm>
+          <a:prstGeom prst="rect">
+            <a:avLst/>
+          </a:prstGeom>
+          <a:noFill/>
+          <a:ln/>
+        </p:spPr>
+        <p:txBody>
+          <a:bodyPr wrap="square" lIns="0" tIns="0" rIns="0" bIns="0" rtlCol="0" anchor="ctr"/>
+          <a:lstStyle/>
+          <a:p>
+            <a:pPr marL="0" indent="0">
               <a:buNone/>
             </a:pPr>
             <a:r>
               <a:rPr lang="en-US" sz="1400" dirty="0">
                 <a:solidFill>
-                  <a:srgbClr val="CADCFC"/>
+                  <a:srgbClr val="21295C"/>
                 </a:solidFill>
                 <a:latin typeface="Calibri" pitchFamily="34" charset="0"/>
                 <a:ea typeface="Calibri" pitchFamily="34" charset="-122"/>
                 <a:cs typeface="Calibri" pitchFamily="34" charset="-120"/>
               </a:rPr>
               <a:t>AbsRel</a:t>
+            </a:r>
+            <a:endParaRPr lang="en-US" sz="1400" dirty="0"/>
+          </a:p>
+        </p:txBody>
+      </p:sp>
+      <p:sp>
+        <p:nvSpPr>
+          <p:cNvPr id="13" name="Text 11"/>
+          <p:cNvSpPr txBox="1"/>
+          <p:nvPr/>
+        </p:nvSpPr>
+        <p:spPr>
+          <a:xfrm>
+            <a:off x="2651760" y="2834640"/>
+            <a:ext cx="1371600" cy="502920"/>
+          </a:xfrm>
+          <a:prstGeom prst="rect">
+            <a:avLst/>
+          </a:prstGeom>
+          <a:noFill/>
+          <a:ln/>
+        </p:spPr>
+        <p:txBody>
+          <a:bodyPr wrap="square" lIns="0" tIns="0" rIns="0" bIns="0" rtlCol="0" anchor="ctr"/>
+          <a:lstStyle/>
+          <a:p>
+            <a:pPr marL="0" indent="0" algn="ctr">
+              <a:buNone/>
+            </a:pPr>
+            <a:r>
+              <a:rPr lang="en-US" sz="1400" dirty="0">
+                <a:solidFill>
+                  <a:srgbClr val="3A4652"/>
+                </a:solidFill>
+                <a:latin typeface="Calibri" pitchFamily="34" charset="0"/>
+                <a:ea typeface="Calibri" pitchFamily="34" charset="-122"/>
+                <a:cs typeface="Calibri" pitchFamily="34" charset="-120"/>
+              </a:rPr>
+              <a:t>0.191</a:t>
+            </a:r>
+            <a:endParaRPr lang="en-US" sz="1400" dirty="0"/>
+          </a:p>
+        </p:txBody>
+      </p:sp>
+      <p:sp>
+        <p:nvSpPr>
+          <p:cNvPr id="14" name="Text 12"/>
+          <p:cNvSpPr txBox="1"/>
+          <p:nvPr/>
+        </p:nvSpPr>
+        <p:spPr>
+          <a:xfrm>
+            <a:off x="4023360" y="2834640"/>
+            <a:ext cx="1371600" cy="502920"/>
+          </a:xfrm>
+          <a:prstGeom prst="rect">
+            <a:avLst/>
+          </a:prstGeom>
+          <a:noFill/>
+          <a:ln/>
+        </p:spPr>
+        <p:txBody>
+          <a:bodyPr wrap="square" lIns="0" tIns="0" rIns="0" bIns="0" rtlCol="0" anchor="ctr"/>
+          <a:lstStyle/>
+          <a:p>
+            <a:pPr marL="0" indent="0" algn="ctr">
+              <a:buNone/>
+            </a:pPr>
+            <a:r>
+              <a:rPr lang="en-US" sz="1400" b="1" dirty="0">
+                <a:solidFill>
+                  <a:srgbClr val="065A82"/>
+                </a:solidFill>
+                <a:latin typeface="Calibri" pitchFamily="34" charset="0"/>
+                <a:ea typeface="Calibri" pitchFamily="34" charset="-122"/>
+                <a:cs typeface="Calibri" pitchFamily="34" charset="-120"/>
+              </a:rPr>
+              <a:t>0.165</a:t>
+            </a:r>
+            <a:endParaRPr lang="en-US" sz="1400" dirty="0"/>
+          </a:p>
+        </p:txBody>
+      </p:sp>
+      <p:sp>
+        <p:nvSpPr>
+          <p:cNvPr id="15" name="Text 13"/>
+          <p:cNvSpPr txBox="1"/>
+          <p:nvPr/>
+        </p:nvSpPr>
+        <p:spPr>
+          <a:xfrm>
+            <a:off x="822960" y="3337560"/>
+            <a:ext cx="1828800" cy="502920"/>
+          </a:xfrm>
+          <a:prstGeom prst="rect">
+            <a:avLst/>
+          </a:prstGeom>
+          <a:noFill/>
+          <a:ln/>
+        </p:spPr>
+        <p:txBody>
+          <a:bodyPr wrap="square" lIns="0" tIns="0" rIns="0" bIns="0" rtlCol="0" anchor="ctr"/>
+          <a:lstStyle/>
+          <a:p>
+            <a:pPr marL="0" indent="0">
+              <a:buNone/>
+            </a:pPr>
+            <a:r>
+              <a:rPr lang="en-US" sz="1400" dirty="0">
+                <a:solidFill>
+                  <a:srgbClr val="21295C"/>
+                </a:solidFill>
+                <a:latin typeface="Calibri" pitchFamily="34" charset="0"/>
+                <a:ea typeface="Calibri" pitchFamily="34" charset="-122"/>
+                <a:cs typeface="Calibri" pitchFamily="34" charset="-120"/>
+              </a:rPr>
+              <a:t>δ₁</a:t>
+            </a:r>
+            <a:endParaRPr lang="en-US" sz="1400" dirty="0"/>
+          </a:p>
+        </p:txBody>
+      </p:sp>
+      <p:sp>
+        <p:nvSpPr>
+          <p:cNvPr id="16" name="Text 14"/>
+          <p:cNvSpPr txBox="1"/>
+          <p:nvPr/>
+        </p:nvSpPr>
+        <p:spPr>
+          <a:xfrm>
+            <a:off x="2651760" y="3337560"/>
+            <a:ext cx="1371600" cy="502920"/>
+          </a:xfrm>
+          <a:prstGeom prst="rect">
+            <a:avLst/>
+          </a:prstGeom>
+          <a:noFill/>
+          <a:ln/>
+        </p:spPr>
+        <p:txBody>
+          <a:bodyPr wrap="square" lIns="0" tIns="0" rIns="0" bIns="0" rtlCol="0" anchor="ctr"/>
+          <a:lstStyle/>
+          <a:p>
+            <a:pPr marL="0" indent="0" algn="ctr">
+              <a:buNone/>
+            </a:pPr>
+            <a:r>
+              <a:rPr lang="en-US" sz="1400" dirty="0">
+                <a:solidFill>
+                  <a:srgbClr val="3A4652"/>
+                </a:solidFill>
+                <a:latin typeface="Calibri" pitchFamily="34" charset="0"/>
+                <a:ea typeface="Calibri" pitchFamily="34" charset="-122"/>
+                <a:cs typeface="Calibri" pitchFamily="34" charset="-120"/>
+              </a:rPr>
+              <a:t>0.714</a:t>
+            </a:r>
+            <a:endParaRPr lang="en-US" sz="1400" dirty="0"/>
+          </a:p>
+        </p:txBody>
+      </p:sp>
+      <p:sp>
+        <p:nvSpPr>
+          <p:cNvPr id="17" name="Text 15"/>
+          <p:cNvSpPr txBox="1"/>
+          <p:nvPr/>
+        </p:nvSpPr>
+        <p:spPr>
+          <a:xfrm>
+            <a:off x="4023360" y="3337560"/>
+            <a:ext cx="1371600" cy="502920"/>
+          </a:xfrm>
+          <a:prstGeom prst="rect">
+            <a:avLst/>
+          </a:prstGeom>
+          <a:noFill/>
+          <a:ln/>
+        </p:spPr>
+        <p:txBody>
+          <a:bodyPr wrap="square" lIns="0" tIns="0" rIns="0" bIns="0" rtlCol="0" anchor="ctr"/>
+          <a:lstStyle/>
+          <a:p>
+            <a:pPr marL="0" indent="0" algn="ctr">
+              <a:buNone/>
+            </a:pPr>
+            <a:r>
+              <a:rPr lang="en-US" sz="1400" b="1" dirty="0">
+                <a:solidFill>
+                  <a:srgbClr val="065A82"/>
+                </a:solidFill>
+                <a:latin typeface="Calibri" pitchFamily="34" charset="0"/>
+                <a:ea typeface="Calibri" pitchFamily="34" charset="-122"/>
+                <a:cs typeface="Calibri" pitchFamily="34" charset="-120"/>
+              </a:rPr>
+              <a:t>0.781</a:t>
+            </a:r>
+            <a:endParaRPr lang="en-US" sz="1400" dirty="0"/>
+          </a:p>
+        </p:txBody>
+      </p:sp>
+      <p:sp>
+        <p:nvSpPr>
+          <p:cNvPr id="18" name="Shape 16"/>
+          <p:cNvSpPr/>
+          <p:nvPr/>
+        </p:nvSpPr>
+        <p:spPr>
+          <a:xfrm>
+            <a:off x="640080" y="3840480"/>
+            <a:ext cx="4846320" cy="502920"/>
+          </a:xfrm>
+          <a:prstGeom prst="rect">
+            <a:avLst/>
+          </a:prstGeom>
+          <a:solidFill>
+            <a:srgbClr val="F4F7FA"/>
+          </a:solidFill>
+          <a:ln/>
+        </p:spPr>
+      </p:sp>
+      <p:sp>
+        <p:nvSpPr>
+          <p:cNvPr id="19" name="Text 17"/>
+          <p:cNvSpPr txBox="1"/>
+          <p:nvPr/>
+        </p:nvSpPr>
+        <p:spPr>
+          <a:xfrm>
+            <a:off x="822960" y="3840480"/>
+            <a:ext cx="1828800" cy="502920"/>
+          </a:xfrm>
+          <a:prstGeom prst="rect">
+            <a:avLst/>
+          </a:prstGeom>
+          <a:noFill/>
+          <a:ln/>
+        </p:spPr>
+        <p:txBody>
+          <a:bodyPr wrap="square" lIns="0" tIns="0" rIns="0" bIns="0" rtlCol="0" anchor="ctr"/>
+          <a:lstStyle/>
+          <a:p>
+            <a:pPr marL="0" indent="0">
+              <a:buNone/>
+            </a:pPr>
+            <a:r>
+              <a:rPr lang="en-US" sz="1400" dirty="0">
+                <a:solidFill>
+                  <a:srgbClr val="21295C"/>
+                </a:solidFill>
+                <a:latin typeface="Calibri" pitchFamily="34" charset="0"/>
+                <a:ea typeface="Calibri" pitchFamily="34" charset="-122"/>
+                <a:cs typeface="Calibri" pitchFamily="34" charset="-120"/>
+              </a:rPr>
+              <a:t>δ₂</a:t>
+            </a:r>
+            <a:endParaRPr lang="en-US" sz="1400" dirty="0"/>
+          </a:p>
+        </p:txBody>
+      </p:sp>
+      <p:sp>
+        <p:nvSpPr>
+          <p:cNvPr id="20" name="Text 18"/>
+          <p:cNvSpPr txBox="1"/>
+          <p:nvPr/>
+        </p:nvSpPr>
+        <p:spPr>
+          <a:xfrm>
+            <a:off x="2651760" y="3840480"/>
+            <a:ext cx="1371600" cy="502920"/>
+          </a:xfrm>
+          <a:prstGeom prst="rect">
+            <a:avLst/>
+          </a:prstGeom>
+          <a:noFill/>
+          <a:ln/>
+        </p:spPr>
+        <p:txBody>
+          <a:bodyPr wrap="square" lIns="0" tIns="0" rIns="0" bIns="0" rtlCol="0" anchor="ctr"/>
+          <a:lstStyle/>
+          <a:p>
+            <a:pPr marL="0" indent="0" algn="ctr">
+              <a:buNone/>
+            </a:pPr>
+            <a:r>
+              <a:rPr lang="en-US" sz="1400" dirty="0">
+                <a:solidFill>
+                  <a:srgbClr val="3A4652"/>
+                </a:solidFill>
+                <a:latin typeface="Calibri" pitchFamily="34" charset="0"/>
+                <a:ea typeface="Calibri" pitchFamily="34" charset="-122"/>
+                <a:cs typeface="Calibri" pitchFamily="34" charset="-120"/>
+              </a:rPr>
+              <a:t>0.924</a:t>
+            </a:r>
+            <a:endParaRPr lang="en-US" sz="1400" dirty="0"/>
+          </a:p>
+        </p:txBody>
+      </p:sp>
+      <p:sp>
+        <p:nvSpPr>
+          <p:cNvPr id="21" name="Text 19"/>
+          <p:cNvSpPr txBox="1"/>
+          <p:nvPr/>
+        </p:nvSpPr>
+        <p:spPr>
+          <a:xfrm>
+            <a:off x="4023360" y="3840480"/>
+            <a:ext cx="1371600" cy="502920"/>
+          </a:xfrm>
+          <a:prstGeom prst="rect">
+            <a:avLst/>
+          </a:prstGeom>
+          <a:noFill/>
+          <a:ln/>
+        </p:spPr>
+        <p:txBody>
+          <a:bodyPr wrap="square" lIns="0" tIns="0" rIns="0" bIns="0" rtlCol="0" anchor="ctr"/>
+          <a:lstStyle/>
+          <a:p>
+            <a:pPr marL="0" indent="0" algn="ctr">
+              <a:buNone/>
+            </a:pPr>
+            <a:r>
+              <a:rPr lang="en-US" sz="1400" b="1" dirty="0">
+                <a:solidFill>
+                  <a:srgbClr val="065A82"/>
+                </a:solidFill>
+                <a:latin typeface="Calibri" pitchFamily="34" charset="0"/>
+                <a:ea typeface="Calibri" pitchFamily="34" charset="-122"/>
+                <a:cs typeface="Calibri" pitchFamily="34" charset="-120"/>
+              </a:rPr>
+              <a:t>0.946</a:t>
+            </a:r>
+            <a:endParaRPr lang="en-US" sz="1400" dirty="0"/>
+          </a:p>
+        </p:txBody>
+      </p:sp>
+      <p:sp>
+        <p:nvSpPr>
+          <p:cNvPr id="22" name="Text 20"/>
+          <p:cNvSpPr txBox="1"/>
+          <p:nvPr/>
+        </p:nvSpPr>
+        <p:spPr>
+          <a:xfrm>
+            <a:off x="822960" y="4343400"/>
+            <a:ext cx="1828800" cy="502920"/>
+          </a:xfrm>
+          <a:prstGeom prst="rect">
+            <a:avLst/>
+          </a:prstGeom>
+          <a:noFill/>
+          <a:ln/>
+        </p:spPr>
+        <p:txBody>
+          <a:bodyPr wrap="square" lIns="0" tIns="0" rIns="0" bIns="0" rtlCol="0" anchor="ctr"/>
+          <a:lstStyle/>
+          <a:p>
+            <a:pPr marL="0" indent="0">
+              <a:buNone/>
+            </a:pPr>
+            <a:r>
+              <a:rPr lang="en-US" sz="1400" dirty="0">
+                <a:solidFill>
+                  <a:srgbClr val="21295C"/>
+                </a:solidFill>
+                <a:latin typeface="Calibri" pitchFamily="34" charset="0"/>
+                <a:ea typeface="Calibri" pitchFamily="34" charset="-122"/>
+                <a:cs typeface="Calibri" pitchFamily="34" charset="-120"/>
+              </a:rPr>
+              <a:t>δ₃</a:t>
+            </a:r>
+            <a:endParaRPr lang="en-US" sz="1400" dirty="0"/>
+          </a:p>
+        </p:txBody>
+      </p:sp>
+      <p:sp>
+        <p:nvSpPr>
+          <p:cNvPr id="23" name="Text 21"/>
+          <p:cNvSpPr txBox="1"/>
+          <p:nvPr/>
+        </p:nvSpPr>
+        <p:spPr>
+          <a:xfrm>
+            <a:off x="2651760" y="4343400"/>
+            <a:ext cx="1371600" cy="502920"/>
+          </a:xfrm>
+          <a:prstGeom prst="rect">
+            <a:avLst/>
+          </a:prstGeom>
+          <a:noFill/>
+          <a:ln/>
+        </p:spPr>
+        <p:txBody>
+          <a:bodyPr wrap="square" lIns="0" tIns="0" rIns="0" bIns="0" rtlCol="0" anchor="ctr"/>
+          <a:lstStyle/>
+          <a:p>
+            <a:pPr marL="0" indent="0" algn="ctr">
+              <a:buNone/>
+            </a:pPr>
+            <a:r>
+              <a:rPr lang="en-US" sz="1400" dirty="0">
+                <a:solidFill>
+                  <a:srgbClr val="3A4652"/>
+                </a:solidFill>
+                <a:latin typeface="Calibri" pitchFamily="34" charset="0"/>
+                <a:ea typeface="Calibri" pitchFamily="34" charset="-122"/>
+                <a:cs typeface="Calibri" pitchFamily="34" charset="-120"/>
+              </a:rPr>
+              <a:t>0.978</a:t>
+            </a:r>
+            <a:endParaRPr lang="en-US" sz="1400" dirty="0"/>
+          </a:p>
+        </p:txBody>
+      </p:sp>
+      <p:sp>
+        <p:nvSpPr>
+          <p:cNvPr id="24" name="Text 22"/>
+          <p:cNvSpPr txBox="1"/>
+          <p:nvPr/>
+        </p:nvSpPr>
+        <p:spPr>
+          <a:xfrm>
+            <a:off x="4023360" y="4343400"/>
+            <a:ext cx="1371600" cy="502920"/>
+          </a:xfrm>
+          <a:prstGeom prst="rect">
+            <a:avLst/>
+          </a:prstGeom>
+          <a:noFill/>
+          <a:ln/>
+        </p:spPr>
+        <p:txBody>
+          <a:bodyPr wrap="square" lIns="0" tIns="0" rIns="0" bIns="0" rtlCol="0" anchor="ctr"/>
+          <a:lstStyle/>
+          <a:p>
+            <a:pPr marL="0" indent="0" algn="ctr">
+              <a:buNone/>
+            </a:pPr>
+            <a:r>
+              <a:rPr lang="en-US" sz="1400" b="1" dirty="0">
+                <a:solidFill>
+                  <a:srgbClr val="065A82"/>
+                </a:solidFill>
+                <a:latin typeface="Calibri" pitchFamily="34" charset="0"/>
+                <a:ea typeface="Calibri" pitchFamily="34" charset="-122"/>
+                <a:cs typeface="Calibri" pitchFamily="34" charset="-120"/>
+              </a:rPr>
+              <a:t>0.986</a:t>
             </a:r>
             <a:endParaRPr lang="en-US" sz="1400" dirty="0"/>
           </a:p>
@@ -5173,108 +6006,42 @@
       </p:sp>
       <p:graphicFrame>
         <p:nvGraphicFramePr>
-          <p:cNvPr id="10" name="Chart 0" descr=""/>
+          <p:cNvPr id="25" name="Chart 0"/>
           <p:cNvGraphicFramePr/>
           <p:nvPr/>
         </p:nvGraphicFramePr>
         <p:xfrm>
-          <a:off x="6035040" y="1783080"/>
-          <a:ext cx="5486400" cy="2377440"/>
+          <a:off x="5852160" y="1783080"/>
+          <a:ext cx="5669280" cy="3108960"/>
         </p:xfrm>
-        <a:graphic xmlns:a="http://schemas.openxmlformats.org/drawingml/2006/main">
+        <a:graphic>
           <a:graphicData uri="http://schemas.openxmlformats.org/drawingml/2006/chart">
-            <c:chart xmlns:c="http://schemas.openxmlformats.org/drawingml/2006/chart" r:id="rId1"/>
+            <c:chart xmlns:c="http://schemas.openxmlformats.org/drawingml/2006/chart" xmlns:r="http://schemas.openxmlformats.org/officeDocument/2006/relationships" r:id="rId3"/>
           </a:graphicData>
         </a:graphic>
       </p:graphicFrame>
       <p:sp>
         <p:nvSpPr>
-          <p:cNvPr id="11" name="Shape 8"/>
-          <p:cNvSpPr/>
-          <p:nvPr/>
-        </p:nvSpPr>
-        <p:spPr>
-          <a:xfrm>
-            <a:off x="640080" y="4251960"/>
-            <a:ext cx="10881360" cy="1417320"/>
-          </a:xfrm>
-          <a:prstGeom prst="roundRect">
-            <a:avLst>
-              <a:gd name="adj" fmla="val 5161"/>
-            </a:avLst>
-          </a:prstGeom>
-          <a:solidFill>
-            <a:srgbClr val="F4F7FA"/>
-          </a:solidFill>
-          <a:ln w="12700">
-            <a:solidFill>
-              <a:srgbClr val="DCE4EC"/>
-            </a:solidFill>
-            <a:prstDash val="solid"/>
-          </a:ln>
-        </p:spPr>
-      </p:sp>
-      <p:sp>
-        <p:nvSpPr>
-          <p:cNvPr id="12" name="Text 9"/>
-          <p:cNvSpPr txBox="1"/>
-          <p:nvPr/>
-        </p:nvSpPr>
-        <p:spPr>
-          <a:xfrm>
-            <a:off x="960120" y="4434840"/>
-            <a:ext cx="10241280" cy="274320"/>
-          </a:xfrm>
-          <a:prstGeom prst="rect">
-            <a:avLst/>
-          </a:prstGeom>
-          <a:noFill/>
-          <a:ln/>
-        </p:spPr>
-        <p:txBody>
-          <a:bodyPr wrap="square" lIns="0" tIns="0" rIns="0" bIns="0" rtlCol="0" anchor="ctr"/>
-          <a:lstStyle/>
-          <a:p>
-            <a:pPr indent="0" marL="0">
-              <a:buNone/>
-            </a:pPr>
-            <a:r>
-              <a:rPr lang="en-US" sz="1400" b="1" dirty="0">
-                <a:solidFill>
-                  <a:srgbClr val="21295C"/>
-                </a:solidFill>
-                <a:latin typeface="Calibri" pitchFamily="34" charset="0"/>
-                <a:ea typeface="Calibri" pitchFamily="34" charset="-122"/>
-                <a:cs typeface="Calibri" pitchFamily="34" charset="-120"/>
-              </a:rPr>
-              <a:t>Reading the numbers</a:t>
-            </a:r>
-            <a:endParaRPr lang="en-US" sz="1400" dirty="0"/>
-          </a:p>
-        </p:txBody>
-      </p:sp>
-      <p:sp>
-        <p:nvSpPr>
-          <p:cNvPr id="13" name="Text 10"/>
-          <p:cNvSpPr txBox="1"/>
-          <p:nvPr/>
-        </p:nvSpPr>
-        <p:spPr>
-          <a:xfrm>
-            <a:off x="960120" y="4754880"/>
-            <a:ext cx="10241280" cy="777240"/>
-          </a:xfrm>
-          <a:prstGeom prst="rect">
-            <a:avLst/>
-          </a:prstGeom>
-          <a:noFill/>
-          <a:ln/>
-        </p:spPr>
-        <p:txBody>
-          <a:bodyPr wrap="square" lIns="0" tIns="0" rIns="0" bIns="0" rtlCol="0" anchor="ctr"/>
-          <a:lstStyle/>
-          <a:p>
-            <a:pPr indent="0" marL="0">
+          <p:cNvPr id="26" name="Text 23"/>
+          <p:cNvSpPr txBox="1"/>
+          <p:nvPr/>
+        </p:nvSpPr>
+        <p:spPr>
+          <a:xfrm>
+            <a:off x="640080" y="5120640"/>
+            <a:ext cx="10881360" cy="640080"/>
+          </a:xfrm>
+          <a:prstGeom prst="rect">
+            <a:avLst/>
+          </a:prstGeom>
+          <a:noFill/>
+          <a:ln/>
+        </p:spPr>
+        <p:txBody>
+          <a:bodyPr wrap="square" lIns="0" tIns="0" rIns="0" bIns="0" rtlCol="0" anchor="ctr"/>
+          <a:lstStyle/>
+          <a:p>
+            <a:pPr marL="0" indent="0">
               <a:lnSpc>
                 <a:spcPts val="1800"/>
               </a:lnSpc>
@@ -5289,7 +6056,7 @@
                 <a:ea typeface="Calibri" pitchFamily="34" charset="-122"/>
                 <a:cs typeface="Calibri" pitchFamily="34" charset="-120"/>
               </a:rPr>
-              <a:t>Typical error around 70 cm, roughly 20% relative. Comparable to FastDepth-class results on a fraction of the data. Training loss fell to 0.071 while validation flattened near 0.185 from epoch 12 — mild overfitting, expected with 1,159 training images against 11M parameters.</a:t>
+              <a:t>ResNet34 is better on every depth metric. Horizontal-flip augmentation and best-epoch checkpointing narrowed the train–validation gap from 0.114 to 0.096.</a:t>
             </a:r>
             <a:endParaRPr lang="en-US" sz="1300" dirty="0"/>
           </a:p>
@@ -5311,6 +6078,7 @@
         <a:solidFill>
           <a:srgbClr val="21295C"/>
         </a:solidFill>
+        <a:effectLst/>
       </p:bgPr>
     </p:bg>
     <p:spTree>
@@ -5348,7 +6116,7 @@
           <a:bodyPr wrap="square" lIns="0" tIns="0" rIns="0" bIns="0" rtlCol="0" anchor="ctr"/>
           <a:lstStyle/>
           <a:p>
-            <a:pPr indent="0" marL="0">
+            <a:pPr marL="0" indent="0">
               <a:buNone/>
             </a:pPr>
             <a:r>
@@ -5387,7 +6155,7 @@
           <a:bodyPr wrap="square" lIns="0" tIns="0" rIns="0" bIns="0" rtlCol="0" anchor="ctr"/>
           <a:lstStyle/>
           <a:p>
-            <a:pPr indent="0" marL="0">
+            <a:pPr marL="0" indent="0">
               <a:buNone/>
             </a:pPr>
             <a:r>
@@ -5453,11 +6221,11 @@
           <a:bodyPr wrap="square" lIns="0" tIns="0" rIns="0" bIns="0" rtlCol="0" anchor="ctr"/>
           <a:lstStyle/>
           <a:p>
-            <a:pPr indent="0" marL="0">
-              <a:buNone/>
-            </a:pPr>
-            <a:r>
-              <a:rPr lang="en-US" sz="1100" b="1" spc="100" kern="0" dirty="0">
+            <a:pPr marL="0" indent="0">
+              <a:buNone/>
+            </a:pPr>
+            <a:r>
+              <a:rPr lang="en-US" sz="1100" b="1" kern="0" spc="100" dirty="0">
                 <a:solidFill>
                   <a:srgbClr val="8A99A8"/>
                 </a:solidFill>
@@ -5492,7 +6260,7 @@
           <a:bodyPr wrap="square" lIns="0" tIns="0" rIns="0" bIns="0" rtlCol="0" anchor="ctr"/>
           <a:lstStyle/>
           <a:p>
-            <a:pPr indent="0" marL="0">
+            <a:pPr marL="0" indent="0">
               <a:buNone/>
             </a:pPr>
             <a:r>
@@ -5531,7 +6299,7 @@
           <a:bodyPr wrap="square" lIns="0" tIns="0" rIns="0" bIns="0" rtlCol="0" anchor="ctr"/>
           <a:lstStyle/>
           <a:p>
-            <a:pPr indent="0" marL="0">
+            <a:pPr marL="0" indent="0">
               <a:buNone/>
             </a:pPr>
             <a:r>
@@ -5570,7 +6338,7 @@
           <a:bodyPr wrap="square" lIns="0" tIns="0" rIns="0" bIns="0" rtlCol="0" anchor="ctr"/>
           <a:lstStyle/>
           <a:p>
-            <a:pPr indent="0" marL="0">
+            <a:pPr marL="0" indent="0">
               <a:buNone/>
             </a:pPr>
             <a:r>
@@ -5609,7 +6377,7 @@
           <a:bodyPr wrap="square" lIns="0" tIns="0" rIns="0" bIns="0" rtlCol="0" anchor="ctr"/>
           <a:lstStyle/>
           <a:p>
-            <a:pPr indent="0" marL="0">
+            <a:pPr marL="0" indent="0">
               <a:lnSpc>
                 <a:spcPts val="1800"/>
               </a:lnSpc>
@@ -5678,11 +6446,11 @@
           <a:bodyPr wrap="square" lIns="0" tIns="0" rIns="0" bIns="0" rtlCol="0" anchor="ctr"/>
           <a:lstStyle/>
           <a:p>
-            <a:pPr indent="0" marL="0">
-              <a:buNone/>
-            </a:pPr>
-            <a:r>
-              <a:rPr lang="en-US" sz="1100" b="1" spc="100" kern="0" dirty="0">
+            <a:pPr marL="0" indent="0">
+              <a:buNone/>
+            </a:pPr>
+            <a:r>
+              <a:rPr lang="en-US" sz="1100" b="1" kern="0" spc="100" dirty="0">
                 <a:solidFill>
                   <a:srgbClr val="CADCFC"/>
                 </a:solidFill>
@@ -5717,7 +6485,7 @@
           <a:bodyPr wrap="square" lIns="0" tIns="0" rIns="0" bIns="0" rtlCol="0" anchor="ctr"/>
           <a:lstStyle/>
           <a:p>
-            <a:pPr indent="0" marL="0">
+            <a:pPr marL="0" indent="0">
               <a:buNone/>
             </a:pPr>
             <a:r>
@@ -5756,7 +6524,7 @@
           <a:bodyPr wrap="square" lIns="0" tIns="0" rIns="0" bIns="0" rtlCol="0" anchor="ctr"/>
           <a:lstStyle/>
           <a:p>
-            <a:pPr indent="0" marL="0">
+            <a:pPr marL="0" indent="0">
               <a:buNone/>
             </a:pPr>
             <a:r>
@@ -5795,7 +6563,7 @@
           <a:bodyPr wrap="square" lIns="0" tIns="0" rIns="0" bIns="0" rtlCol="0" anchor="ctr"/>
           <a:lstStyle/>
           <a:p>
-            <a:pPr indent="0" marL="0">
+            <a:pPr marL="0" indent="0">
               <a:buNone/>
             </a:pPr>
             <a:r>
@@ -5834,7 +6602,7 @@
           <a:bodyPr wrap="square" lIns="0" tIns="0" rIns="0" bIns="0" rtlCol="0" anchor="ctr"/>
           <a:lstStyle/>
           <a:p>
-            <a:pPr indent="0" marL="0">
+            <a:pPr marL="0" indent="0">
               <a:lnSpc>
                 <a:spcPts val="1800"/>
               </a:lnSpc>
@@ -5876,7 +6644,7 @@
           <a:bodyPr wrap="square" lIns="0" tIns="0" rIns="0" bIns="0" rtlCol="0" anchor="ctr"/>
           <a:lstStyle/>
           <a:p>
-            <a:pPr indent="0" marL="0">
+            <a:pPr marL="0" indent="0">
               <a:lnSpc>
                 <a:spcPts val="1800"/>
               </a:lnSpc>
@@ -5913,6 +6681,7 @@
         <a:solidFill>
           <a:srgbClr val="FFFFFF"/>
         </a:solidFill>
+        <a:effectLst/>
       </p:bgPr>
     </p:bg>
     <p:spTree>
@@ -5950,7 +6719,7 @@
           <a:bodyPr wrap="square" lIns="0" tIns="0" rIns="0" bIns="0" rtlCol="0" anchor="ctr"/>
           <a:lstStyle/>
           <a:p>
-            <a:pPr indent="0" marL="0">
+            <a:pPr marL="0" indent="0">
               <a:buNone/>
             </a:pPr>
             <a:r>
@@ -5989,7 +6758,7 @@
           <a:bodyPr wrap="square" lIns="0" tIns="0" rIns="0" bIns="0" rtlCol="0" anchor="ctr"/>
           <a:lstStyle/>
           <a:p>
-            <a:pPr indent="0" marL="0">
+            <a:pPr marL="0" indent="0">
               <a:buNone/>
             </a:pPr>
             <a:r>
@@ -6009,17 +6778,17 @@
       </p:sp>
       <p:graphicFrame>
         <p:nvGraphicFramePr>
-          <p:cNvPr id="4" name="Chart 0" descr=""/>
+          <p:cNvPr id="4" name="Chart 0"/>
           <p:cNvGraphicFramePr/>
           <p:nvPr/>
         </p:nvGraphicFramePr>
         <p:xfrm>
           <a:off x="640080" y="1737360"/>
-          <a:ext cx="6766560" cy="3108960"/>
+          <a:ext cx="6766560" cy="3200400"/>
         </p:xfrm>
-        <a:graphic xmlns:a="http://schemas.openxmlformats.org/drawingml/2006/main">
+        <a:graphic>
           <a:graphicData uri="http://schemas.openxmlformats.org/drawingml/2006/chart">
-            <c:chart xmlns:c="http://schemas.openxmlformats.org/drawingml/2006/chart" r:id="rId1"/>
+            <c:chart xmlns:c="http://schemas.openxmlformats.org/drawingml/2006/chart" xmlns:r="http://schemas.openxmlformats.org/officeDocument/2006/relationships" r:id="rId3"/>
           </a:graphicData>
         </a:graphic>
       </p:graphicFrame>
@@ -6032,11 +6801,11 @@
         <p:spPr>
           <a:xfrm>
             <a:off x="7772400" y="1737360"/>
-            <a:ext cx="3749040" cy="1417320"/>
+            <a:ext cx="3749040" cy="1463040"/>
           </a:xfrm>
           <a:prstGeom prst="roundRect">
             <a:avLst>
-              <a:gd name="adj" fmla="val 6452"/>
+              <a:gd name="adj" fmla="val 6250"/>
             </a:avLst>
           </a:prstGeom>
           <a:solidFill>
@@ -6066,7 +6835,7 @@
           <a:bodyPr wrap="square" lIns="0" tIns="0" rIns="0" bIns="0" rtlCol="0" anchor="ctr"/>
           <a:lstStyle/>
           <a:p>
-            <a:pPr algn="ctr" indent="0" marL="0">
+            <a:pPr marL="0" indent="0" algn="ctr">
               <a:buNone/>
             </a:pPr>
             <a:r>
@@ -6078,7 +6847,7 @@
                 <a:ea typeface="Cambria" pitchFamily="34" charset="-122"/>
                 <a:cs typeface="Cambria" pitchFamily="34" charset="-120"/>
               </a:rPr>
-              <a:t>0.984</a:t>
+              <a:t>0.986</a:t>
             </a:r>
             <a:endParaRPr lang="en-US" sz="3800" dirty="0"/>
           </a:p>
@@ -6105,11 +6874,11 @@
           <a:bodyPr wrap="square" lIns="0" tIns="0" rIns="0" bIns="0" rtlCol="0" anchor="ctr"/>
           <a:lstStyle/>
           <a:p>
-            <a:pPr algn="ctr" indent="0" marL="0">
-              <a:buNone/>
-            </a:pPr>
-            <a:r>
-              <a:rPr lang="en-US" sz="1300" dirty="0">
+            <a:pPr marL="0" indent="0" algn="ctr">
+              <a:buNone/>
+            </a:pPr>
+            <a:r>
+              <a:rPr lang="en-US" sz="1200" dirty="0">
                 <a:solidFill>
                   <a:srgbClr val="CADCFC"/>
                 </a:solidFill>
@@ -6117,9 +6886,9 @@
                 <a:ea typeface="Calibri" pitchFamily="34" charset="-122"/>
                 <a:cs typeface="Calibri" pitchFamily="34" charset="-120"/>
               </a:rPr>
-              <a:t>Combined AUROC</a:t>
-            </a:r>
-            <a:endParaRPr lang="en-US" sz="1300" dirty="0"/>
+              <a:t>Best combined AUROC (ResNet18)</a:t>
+            </a:r>
+            <a:endParaRPr lang="en-US" sz="1200" dirty="0"/>
           </a:p>
         </p:txBody>
       </p:sp>
@@ -6131,12 +6900,12 @@
         </p:nvSpPr>
         <p:spPr>
           <a:xfrm>
-            <a:off x="7772400" y="3429000"/>
-            <a:ext cx="3749040" cy="1417320"/>
+            <a:off x="7772400" y="3474720"/>
+            <a:ext cx="3749040" cy="1463040"/>
           </a:xfrm>
           <a:prstGeom prst="roundRect">
             <a:avLst>
-              <a:gd name="adj" fmla="val 6452"/>
+              <a:gd name="adj" fmla="val 6250"/>
             </a:avLst>
           </a:prstGeom>
           <a:solidFill>
@@ -6158,7 +6927,7 @@
         </p:nvSpPr>
         <p:spPr>
           <a:xfrm>
-            <a:off x="7772400" y="3657600"/>
+            <a:off x="7772400" y="3703320"/>
             <a:ext cx="3749040" cy="685800"/>
           </a:xfrm>
           <a:prstGeom prst="rect">
@@ -6171,7 +6940,7 @@
           <a:bodyPr wrap="square" lIns="0" tIns="0" rIns="0" bIns="0" rtlCol="0" anchor="ctr"/>
           <a:lstStyle/>
           <a:p>
-            <a:pPr algn="ctr" indent="0" marL="0">
+            <a:pPr marL="0" indent="0" algn="ctr">
               <a:buNone/>
             </a:pPr>
             <a:r>
@@ -6183,7 +6952,7 @@
                 <a:ea typeface="Cambria" pitchFamily="34" charset="-122"/>
                 <a:cs typeface="Cambria" pitchFamily="34" charset="-120"/>
               </a:rPr>
-              <a:t>0.103</a:t>
+              <a:t>0.083</a:t>
             </a:r>
             <a:endParaRPr lang="en-US" sz="3800" dirty="0"/>
           </a:p>
@@ -6197,7 +6966,7 @@
         </p:nvSpPr>
         <p:spPr>
           <a:xfrm>
-            <a:off x="7772400" y="4389120"/>
+            <a:off x="7772400" y="4434840"/>
             <a:ext cx="3749040" cy="274320"/>
           </a:xfrm>
           <a:prstGeom prst="rect">
@@ -6210,11 +6979,11 @@
           <a:bodyPr wrap="square" lIns="0" tIns="0" rIns="0" bIns="0" rtlCol="0" anchor="ctr"/>
           <a:lstStyle/>
           <a:p>
-            <a:pPr algn="ctr" indent="0" marL="0">
-              <a:buNone/>
-            </a:pPr>
-            <a:r>
-              <a:rPr lang="en-US" sz="1300" dirty="0">
+            <a:pPr marL="0" indent="0" algn="ctr">
+              <a:buNone/>
+            </a:pPr>
+            <a:r>
+              <a:rPr lang="en-US" sz="1200" dirty="0">
                 <a:solidFill>
                   <a:srgbClr val="6B7885"/>
                 </a:solidFill>
@@ -6222,9 +6991,9 @@
                 <a:ea typeface="Calibri" pitchFamily="34" charset="-122"/>
                 <a:cs typeface="Calibri" pitchFamily="34" charset="-120"/>
               </a:rPr>
-              <a:t>FPR at 95% recall</a:t>
-            </a:r>
-            <a:endParaRPr lang="en-US" sz="1300" dirty="0"/>
+              <a:t>FPR at 95% OOD recall</a:t>
+            </a:r>
+            <a:endParaRPr lang="en-US" sz="1200" dirty="0"/>
           </a:p>
         </p:txBody>
       </p:sp>
@@ -6249,7 +7018,7 @@
           <a:bodyPr wrap="square" lIns="0" tIns="0" rIns="0" bIns="0" rtlCol="0" anchor="ctr"/>
           <a:lstStyle/>
           <a:p>
-            <a:pPr indent="0" marL="0">
+            <a:pPr marL="0" indent="0">
               <a:buNone/>
             </a:pPr>
             <a:r>
@@ -6261,7 +7030,7 @@
                 <a:ea typeface="Calibri" pitchFamily="34" charset="-122"/>
                 <a:cs typeface="Calibri" pitchFamily="34" charset="-120"/>
               </a:rPr>
-              <a:t>Layer 3 beats layer 4</a:t>
+              <a:t>Signal migrates with depth</a:t>
             </a:r>
             <a:endParaRPr lang="en-US" sz="1400" dirty="0"/>
           </a:p>
@@ -6276,26 +7045,26 @@
         <p:spPr>
           <a:xfrm>
             <a:off x="640080" y="5367528"/>
-            <a:ext cx="3383280" cy="548640"/>
-          </a:xfrm>
-          <a:prstGeom prst="rect">
-            <a:avLst/>
-          </a:prstGeom>
-          <a:noFill/>
-          <a:ln/>
-        </p:spPr>
-        <p:txBody>
-          <a:bodyPr wrap="square" lIns="0" tIns="0" rIns="0" bIns="0" rtlCol="0" anchor="ctr"/>
-          <a:lstStyle/>
-          <a:p>
-            <a:pPr indent="0" marL="0">
+            <a:ext cx="3383280" cy="640080"/>
+          </a:xfrm>
+          <a:prstGeom prst="rect">
+            <a:avLst/>
+          </a:prstGeom>
+          <a:noFill/>
+          <a:ln/>
+        </p:spPr>
+        <p:txBody>
+          <a:bodyPr wrap="square" lIns="0" tIns="0" rIns="0" bIns="0" rtlCol="0" anchor="ctr"/>
+          <a:lstStyle/>
+          <a:p>
+            <a:pPr marL="0" indent="0">
               <a:lnSpc>
-                <a:spcPts val="1600"/>
+                <a:spcPts val="1500"/>
               </a:lnSpc>
               <a:buNone/>
             </a:pPr>
             <a:r>
-              <a:rPr lang="en-US" sz="1200" dirty="0">
+              <a:rPr lang="en-US" sz="1100" dirty="0">
                 <a:solidFill>
                   <a:srgbClr val="6B7885"/>
                 </a:solidFill>
@@ -6303,9 +7072,9 @@
                 <a:ea typeface="Calibri" pitchFamily="34" charset="-122"/>
                 <a:cs typeface="Calibri" pitchFamily="34" charset="-120"/>
               </a:rPr>
-              <a:t>Mid-level features separate better than the deepest stage.</a:t>
-            </a:r>
-            <a:endParaRPr lang="en-US" sz="1200" dirty="0"/>
+              <a:t>On ResNet34 layer 1 is strongest and layer 4 weakest — the reverse of ResNet18.</a:t>
+            </a:r>
+            <a:endParaRPr lang="en-US" sz="1100" dirty="0"/>
           </a:p>
         </p:txBody>
       </p:sp>
@@ -6330,7 +7099,7 @@
           <a:bodyPr wrap="square" lIns="0" tIns="0" rIns="0" bIns="0" rtlCol="0" anchor="ctr"/>
           <a:lstStyle/>
           <a:p>
-            <a:pPr indent="0" marL="0">
+            <a:pPr marL="0" indent="0">
               <a:buNone/>
             </a:pPr>
             <a:r>
@@ -6342,7 +7111,7 @@
                 <a:ea typeface="Calibri" pitchFamily="34" charset="-122"/>
                 <a:cs typeface="Calibri" pitchFamily="34" charset="-120"/>
               </a:rPr>
-              <a:t>Combination adds signal</a:t>
+              <a:t>Combination beats every layer</a:t>
             </a:r>
             <a:endParaRPr lang="en-US" sz="1400" dirty="0"/>
           </a:p>
@@ -6357,26 +7126,26 @@
         <p:spPr>
           <a:xfrm>
             <a:off x="4297680" y="5367528"/>
-            <a:ext cx="3383280" cy="548640"/>
-          </a:xfrm>
-          <a:prstGeom prst="rect">
-            <a:avLst/>
-          </a:prstGeom>
-          <a:noFill/>
-          <a:ln/>
-        </p:spPr>
-        <p:txBody>
-          <a:bodyPr wrap="square" lIns="0" tIns="0" rIns="0" bIns="0" rtlCol="0" anchor="ctr"/>
-          <a:lstStyle/>
-          <a:p>
-            <a:pPr indent="0" marL="0">
+            <a:ext cx="3383280" cy="640080"/>
+          </a:xfrm>
+          <a:prstGeom prst="rect">
+            <a:avLst/>
+          </a:prstGeom>
+          <a:noFill/>
+          <a:ln/>
+        </p:spPr>
+        <p:txBody>
+          <a:bodyPr wrap="square" lIns="0" tIns="0" rIns="0" bIns="0" rtlCol="0" anchor="ctr"/>
+          <a:lstStyle/>
+          <a:p>
+            <a:pPr marL="0" indent="0">
               <a:lnSpc>
-                <a:spcPts val="1600"/>
+                <a:spcPts val="1500"/>
               </a:lnSpc>
               <a:buNone/>
             </a:pPr>
             <a:r>
-              <a:rPr lang="en-US" sz="1200" dirty="0">
+              <a:rPr lang="en-US" sz="1100" dirty="0">
                 <a:solidFill>
                   <a:srgbClr val="6B7885"/>
                 </a:solidFill>
@@ -6384,9 +7153,9 @@
                 <a:ea typeface="Calibri" pitchFamily="34" charset="-122"/>
                 <a:cs typeface="Calibri" pitchFamily="34" charset="-120"/>
               </a:rPr>
-              <a:t>Averaging standardised layers beats every layer alone.</a:t>
-            </a:r>
-            <a:endParaRPr lang="en-US" sz="1200" dirty="0"/>
+              <a:t>Averaging standardised layers outperforms each one alone, in both models.</a:t>
+            </a:r>
+            <a:endParaRPr lang="en-US" sz="1100" dirty="0"/>
           </a:p>
         </p:txBody>
       </p:sp>
@@ -6411,7 +7180,7 @@
           <a:bodyPr wrap="square" lIns="0" tIns="0" rIns="0" bIns="0" rtlCol="0" anchor="ctr"/>
           <a:lstStyle/>
           <a:p>
-            <a:pPr indent="0" marL="0">
+            <a:pPr marL="0" indent="0">
               <a:buNone/>
             </a:pPr>
             <a:r>
@@ -6438,26 +7207,26 @@
         <p:spPr>
           <a:xfrm>
             <a:off x="7955280" y="5367528"/>
-            <a:ext cx="3383280" cy="548640"/>
-          </a:xfrm>
-          <a:prstGeom prst="rect">
-            <a:avLst/>
-          </a:prstGeom>
-          <a:noFill/>
-          <a:ln/>
-        </p:spPr>
-        <p:txBody>
-          <a:bodyPr wrap="square" lIns="0" tIns="0" rIns="0" bIns="0" rtlCol="0" anchor="ctr"/>
-          <a:lstStyle/>
-          <a:p>
-            <a:pPr indent="0" marL="0">
+            <a:ext cx="3383280" cy="640080"/>
+          </a:xfrm>
+          <a:prstGeom prst="rect">
+            <a:avLst/>
+          </a:prstGeom>
+          <a:noFill/>
+          <a:ln/>
+        </p:spPr>
+        <p:txBody>
+          <a:bodyPr wrap="square" lIns="0" tIns="0" rIns="0" bIns="0" rtlCol="0" anchor="ctr"/>
+          <a:lstStyle/>
+          <a:p>
+            <a:pPr marL="0" indent="0">
               <a:lnSpc>
-                <a:spcPts val="1600"/>
+                <a:spcPts val="1500"/>
               </a:lnSpc>
               <a:buNone/>
             </a:pPr>
             <a:r>
-              <a:rPr lang="en-US" sz="1200" dirty="0">
+              <a:rPr lang="en-US" sz="1100" dirty="0">
                 <a:solidFill>
                   <a:srgbClr val="6B7885"/>
                 </a:solidFill>
@@ -6465,9 +7234,9 @@
                 <a:ea typeface="Calibri" pitchFamily="34" charset="-122"/>
                 <a:cs typeface="Calibri" pitchFamily="34" charset="-120"/>
               </a:rPr>
-              <a:t>Mean and σ come from NYU; using KITTI would be circular.</a:t>
-            </a:r>
-            <a:endParaRPr lang="en-US" sz="1200" dirty="0"/>
+              <a:t>Mean and σ come from NYU; using KITTI to calibrate would be circular.</a:t>
+            </a:r>
+            <a:endParaRPr lang="en-US" sz="1100" dirty="0"/>
           </a:p>
         </p:txBody>
       </p:sp>
@@ -6485,8 +7254,9 @@
     <p:bg>
       <p:bgPr>
         <a:solidFill>
-          <a:srgbClr val="21295C"/>
+          <a:srgbClr val="FFFFFF"/>
         </a:solidFill>
+        <a:effectLst/>
       </p:bgPr>
     </p:bg>
     <p:spTree>
@@ -6512,30 +7282,810 @@
         <p:spPr>
           <a:xfrm>
             <a:off x="640080" y="502920"/>
-            <a:ext cx="9144000" cy="548640"/>
-          </a:xfrm>
-          <a:prstGeom prst="rect">
-            <a:avLst/>
-          </a:prstGeom>
-          <a:noFill/>
-          <a:ln/>
-        </p:spPr>
-        <p:txBody>
-          <a:bodyPr wrap="square" lIns="0" tIns="0" rIns="0" bIns="0" rtlCol="0" anchor="ctr"/>
-          <a:lstStyle/>
-          <a:p>
-            <a:pPr indent="0" marL="0">
+            <a:ext cx="8229600" cy="548640"/>
+          </a:xfrm>
+          <a:prstGeom prst="rect">
+            <a:avLst/>
+          </a:prstGeom>
+          <a:noFill/>
+          <a:ln/>
+        </p:spPr>
+        <p:txBody>
+          <a:bodyPr wrap="square" lIns="0" tIns="0" rIns="0" bIns="0" rtlCol="0" anchor="ctr"/>
+          <a:lstStyle/>
+          <a:p>
+            <a:pPr marL="0" indent="0">
               <a:buNone/>
             </a:pPr>
             <a:r>
               <a:rPr lang="en-US" sz="3800" b="1" dirty="0">
                 <a:solidFill>
-                  <a:srgbClr val="FFFFFF"/>
+                  <a:srgbClr val="21295C"/>
                 </a:solidFill>
                 <a:latin typeface="Cambria" pitchFamily="34" charset="0"/>
                 <a:ea typeface="Cambria" pitchFamily="34" charset="-122"/>
                 <a:cs typeface="Cambria" pitchFamily="34" charset="-120"/>
               </a:rPr>
+              <a:t>A consistent trade-off</a:t>
+            </a:r>
+            <a:endParaRPr lang="en-US" sz="3800" dirty="0"/>
+          </a:p>
+        </p:txBody>
+      </p:sp>
+      <p:sp>
+        <p:nvSpPr>
+          <p:cNvPr id="3" name="Text 1"/>
+          <p:cNvSpPr txBox="1"/>
+          <p:nvPr/>
+        </p:nvSpPr>
+        <p:spPr>
+          <a:xfrm>
+            <a:off x="640080" y="1143000"/>
+            <a:ext cx="10515600" cy="320040"/>
+          </a:xfrm>
+          <a:prstGeom prst="rect">
+            <a:avLst/>
+          </a:prstGeom>
+          <a:noFill/>
+          <a:ln/>
+        </p:spPr>
+        <p:txBody>
+          <a:bodyPr wrap="square" lIns="0" tIns="0" rIns="0" bIns="0" rtlCol="0" anchor="ctr"/>
+          <a:lstStyle/>
+          <a:p>
+            <a:pPr marL="0" indent="0">
+              <a:buNone/>
+            </a:pPr>
+            <a:r>
+              <a:rPr lang="en-US" sz="1500" dirty="0">
+                <a:solidFill>
+                  <a:srgbClr val="6B7885"/>
+                </a:solidFill>
+                <a:latin typeface="Calibri" pitchFamily="34" charset="0"/>
+                <a:ea typeface="Calibri" pitchFamily="34" charset="-122"/>
+                <a:cs typeface="Calibri" pitchFamily="34" charset="-120"/>
+              </a:rPr>
+              <a:t>Two independent changes both improved depth accuracy and both weakened OOD separation.</a:t>
+            </a:r>
+            <a:endParaRPr lang="en-US" sz="1500" dirty="0"/>
+          </a:p>
+        </p:txBody>
+      </p:sp>
+      <p:sp>
+        <p:nvSpPr>
+          <p:cNvPr id="4" name="Shape 2"/>
+          <p:cNvSpPr/>
+          <p:nvPr/>
+        </p:nvSpPr>
+        <p:spPr>
+          <a:xfrm>
+            <a:off x="640080" y="1828800"/>
+            <a:ext cx="10881360" cy="1371600"/>
+          </a:xfrm>
+          <a:prstGeom prst="roundRect">
+            <a:avLst>
+              <a:gd name="adj" fmla="val 6667"/>
+            </a:avLst>
+          </a:prstGeom>
+          <a:solidFill>
+            <a:srgbClr val="F4F7FA"/>
+          </a:solidFill>
+          <a:ln w="12700">
+            <a:solidFill>
+              <a:srgbClr val="DCE4EC"/>
+            </a:solidFill>
+            <a:prstDash val="solid"/>
+          </a:ln>
+        </p:spPr>
+      </p:sp>
+      <p:sp>
+        <p:nvSpPr>
+          <p:cNvPr id="5" name="Text 3"/>
+          <p:cNvSpPr txBox="1"/>
+          <p:nvPr/>
+        </p:nvSpPr>
+        <p:spPr>
+          <a:xfrm>
+            <a:off x="960120" y="2286000"/>
+            <a:ext cx="2834640" cy="457200"/>
+          </a:xfrm>
+          <a:prstGeom prst="rect">
+            <a:avLst/>
+          </a:prstGeom>
+          <a:noFill/>
+          <a:ln/>
+        </p:spPr>
+        <p:txBody>
+          <a:bodyPr wrap="square" lIns="0" tIns="0" rIns="0" bIns="0" rtlCol="0" anchor="ctr"/>
+          <a:lstStyle/>
+          <a:p>
+            <a:pPr marL="0" indent="0">
+              <a:buNone/>
+            </a:pPr>
+            <a:r>
+              <a:rPr lang="en-US" sz="1800" b="1" dirty="0">
+                <a:solidFill>
+                  <a:srgbClr val="21295C"/>
+                </a:solidFill>
+                <a:latin typeface="Cambria" pitchFamily="34" charset="0"/>
+                <a:ea typeface="Cambria" pitchFamily="34" charset="-122"/>
+                <a:cs typeface="Cambria" pitchFamily="34" charset="-120"/>
+              </a:rPr>
+              <a:t>Flip augmentation</a:t>
+            </a:r>
+            <a:endParaRPr lang="en-US" sz="1800" dirty="0"/>
+          </a:p>
+        </p:txBody>
+      </p:sp>
+      <p:sp>
+        <p:nvSpPr>
+          <p:cNvPr id="6" name="Text 4"/>
+          <p:cNvSpPr txBox="1"/>
+          <p:nvPr/>
+        </p:nvSpPr>
+        <p:spPr>
+          <a:xfrm>
+            <a:off x="4023360" y="2057400"/>
+            <a:ext cx="2194560" cy="274320"/>
+          </a:xfrm>
+          <a:prstGeom prst="rect">
+            <a:avLst/>
+          </a:prstGeom>
+          <a:noFill/>
+          <a:ln/>
+        </p:spPr>
+        <p:txBody>
+          <a:bodyPr wrap="square" lIns="0" tIns="0" rIns="0" bIns="0" rtlCol="0" anchor="ctr"/>
+          <a:lstStyle/>
+          <a:p>
+            <a:pPr marL="0" indent="0">
+              <a:buNone/>
+            </a:pPr>
+            <a:r>
+              <a:rPr lang="en-US" sz="1100" b="1" kern="0" spc="100" dirty="0">
+                <a:solidFill>
+                  <a:srgbClr val="8A99A8"/>
+                </a:solidFill>
+                <a:latin typeface="Calibri" pitchFamily="34" charset="0"/>
+                <a:ea typeface="Calibri" pitchFamily="34" charset="-122"/>
+                <a:cs typeface="Calibri" pitchFamily="34" charset="-120"/>
+              </a:rPr>
+              <a:t>BEST VAL LOSS</a:t>
+            </a:r>
+            <a:endParaRPr lang="en-US" sz="1100" dirty="0"/>
+          </a:p>
+        </p:txBody>
+      </p:sp>
+      <p:sp>
+        <p:nvSpPr>
+          <p:cNvPr id="7" name="Text 5"/>
+          <p:cNvSpPr txBox="1"/>
+          <p:nvPr/>
+        </p:nvSpPr>
+        <p:spPr>
+          <a:xfrm>
+            <a:off x="4023360" y="2377440"/>
+            <a:ext cx="2377440" cy="457200"/>
+          </a:xfrm>
+          <a:prstGeom prst="rect">
+            <a:avLst/>
+          </a:prstGeom>
+          <a:noFill/>
+          <a:ln/>
+        </p:spPr>
+        <p:txBody>
+          <a:bodyPr wrap="square" lIns="0" tIns="0" rIns="0" bIns="0" rtlCol="0" anchor="ctr"/>
+          <a:lstStyle/>
+          <a:p>
+            <a:pPr marL="0" indent="0">
+              <a:buNone/>
+            </a:pPr>
+            <a:r>
+              <a:rPr lang="en-US" sz="2200" b="1" dirty="0">
+                <a:solidFill>
+                  <a:srgbClr val="2E7D4F"/>
+                </a:solidFill>
+                <a:latin typeface="Cambria" pitchFamily="34" charset="0"/>
+                <a:ea typeface="Cambria" pitchFamily="34" charset="-122"/>
+                <a:cs typeface="Cambria" pitchFamily="34" charset="-120"/>
+              </a:rPr>
+              <a:t>0.185  →  0.176</a:t>
+            </a:r>
+            <a:endParaRPr lang="en-US" sz="2200" dirty="0"/>
+          </a:p>
+        </p:txBody>
+      </p:sp>
+      <p:sp>
+        <p:nvSpPr>
+          <p:cNvPr id="8" name="Text 6"/>
+          <p:cNvSpPr txBox="1"/>
+          <p:nvPr/>
+        </p:nvSpPr>
+        <p:spPr>
+          <a:xfrm>
+            <a:off x="6172200" y="2487168"/>
+            <a:ext cx="1280160" cy="274320"/>
+          </a:xfrm>
+          <a:prstGeom prst="rect">
+            <a:avLst/>
+          </a:prstGeom>
+          <a:noFill/>
+          <a:ln/>
+        </p:spPr>
+        <p:txBody>
+          <a:bodyPr wrap="square" lIns="0" tIns="0" rIns="0" bIns="0" rtlCol="0" anchor="ctr"/>
+          <a:lstStyle/>
+          <a:p>
+            <a:pPr marL="0" indent="0">
+              <a:buNone/>
+            </a:pPr>
+            <a:r>
+              <a:rPr lang="en-US" sz="1200" i="1" dirty="0">
+                <a:solidFill>
+                  <a:srgbClr val="2E7D4F"/>
+                </a:solidFill>
+                <a:latin typeface="Calibri" pitchFamily="34" charset="0"/>
+                <a:ea typeface="Calibri" pitchFamily="34" charset="-122"/>
+                <a:cs typeface="Calibri" pitchFamily="34" charset="-120"/>
+              </a:rPr>
+              <a:t>improved</a:t>
+            </a:r>
+            <a:endParaRPr lang="en-US" sz="1200" dirty="0"/>
+          </a:p>
+        </p:txBody>
+      </p:sp>
+      <p:sp>
+        <p:nvSpPr>
+          <p:cNvPr id="9" name="Text 7"/>
+          <p:cNvSpPr txBox="1"/>
+          <p:nvPr/>
+        </p:nvSpPr>
+        <p:spPr>
+          <a:xfrm>
+            <a:off x="7772400" y="2057400"/>
+            <a:ext cx="2194560" cy="274320"/>
+          </a:xfrm>
+          <a:prstGeom prst="rect">
+            <a:avLst/>
+          </a:prstGeom>
+          <a:noFill/>
+          <a:ln/>
+        </p:spPr>
+        <p:txBody>
+          <a:bodyPr wrap="square" lIns="0" tIns="0" rIns="0" bIns="0" rtlCol="0" anchor="ctr"/>
+          <a:lstStyle/>
+          <a:p>
+            <a:pPr marL="0" indent="0">
+              <a:buNone/>
+            </a:pPr>
+            <a:r>
+              <a:rPr lang="en-US" sz="1100" b="1" kern="0" spc="100" dirty="0">
+                <a:solidFill>
+                  <a:srgbClr val="8A99A8"/>
+                </a:solidFill>
+                <a:latin typeface="Calibri" pitchFamily="34" charset="0"/>
+                <a:ea typeface="Calibri" pitchFamily="34" charset="-122"/>
+                <a:cs typeface="Calibri" pitchFamily="34" charset="-120"/>
+              </a:rPr>
+              <a:t>AUROC</a:t>
+            </a:r>
+            <a:endParaRPr lang="en-US" sz="1100" dirty="0"/>
+          </a:p>
+        </p:txBody>
+      </p:sp>
+      <p:sp>
+        <p:nvSpPr>
+          <p:cNvPr id="10" name="Text 8"/>
+          <p:cNvSpPr txBox="1"/>
+          <p:nvPr/>
+        </p:nvSpPr>
+        <p:spPr>
+          <a:xfrm>
+            <a:off x="7772400" y="2377440"/>
+            <a:ext cx="2377440" cy="457200"/>
+          </a:xfrm>
+          <a:prstGeom prst="rect">
+            <a:avLst/>
+          </a:prstGeom>
+          <a:noFill/>
+          <a:ln/>
+        </p:spPr>
+        <p:txBody>
+          <a:bodyPr wrap="square" lIns="0" tIns="0" rIns="0" bIns="0" rtlCol="0" anchor="ctr"/>
+          <a:lstStyle/>
+          <a:p>
+            <a:pPr marL="0" indent="0">
+              <a:buNone/>
+            </a:pPr>
+            <a:r>
+              <a:rPr lang="en-US" sz="2200" b="1" dirty="0">
+                <a:solidFill>
+                  <a:srgbClr val="C4564F"/>
+                </a:solidFill>
+                <a:latin typeface="Cambria" pitchFamily="34" charset="0"/>
+                <a:ea typeface="Cambria" pitchFamily="34" charset="-122"/>
+                <a:cs typeface="Cambria" pitchFamily="34" charset="-120"/>
+              </a:rPr>
+              <a:t>0.984  →  0.973</a:t>
+            </a:r>
+            <a:endParaRPr lang="en-US" sz="2200" dirty="0"/>
+          </a:p>
+        </p:txBody>
+      </p:sp>
+      <p:sp>
+        <p:nvSpPr>
+          <p:cNvPr id="11" name="Text 9"/>
+          <p:cNvSpPr txBox="1"/>
+          <p:nvPr/>
+        </p:nvSpPr>
+        <p:spPr>
+          <a:xfrm>
+            <a:off x="9921240" y="2487168"/>
+            <a:ext cx="1371600" cy="274320"/>
+          </a:xfrm>
+          <a:prstGeom prst="rect">
+            <a:avLst/>
+          </a:prstGeom>
+          <a:noFill/>
+          <a:ln/>
+        </p:spPr>
+        <p:txBody>
+          <a:bodyPr wrap="square" lIns="0" tIns="0" rIns="0" bIns="0" rtlCol="0" anchor="ctr"/>
+          <a:lstStyle/>
+          <a:p>
+            <a:pPr marL="0" indent="0">
+              <a:buNone/>
+            </a:pPr>
+            <a:r>
+              <a:rPr lang="en-US" sz="1200" i="1" dirty="0">
+                <a:solidFill>
+                  <a:srgbClr val="C4564F"/>
+                </a:solidFill>
+                <a:latin typeface="Calibri" pitchFamily="34" charset="0"/>
+                <a:ea typeface="Calibri" pitchFamily="34" charset="-122"/>
+                <a:cs typeface="Calibri" pitchFamily="34" charset="-120"/>
+              </a:rPr>
+              <a:t>degraded</a:t>
+            </a:r>
+            <a:endParaRPr lang="en-US" sz="1200" dirty="0"/>
+          </a:p>
+        </p:txBody>
+      </p:sp>
+      <p:sp>
+        <p:nvSpPr>
+          <p:cNvPr id="12" name="Shape 10"/>
+          <p:cNvSpPr/>
+          <p:nvPr/>
+        </p:nvSpPr>
+        <p:spPr>
+          <a:xfrm>
+            <a:off x="640080" y="3429000"/>
+            <a:ext cx="10881360" cy="1371600"/>
+          </a:xfrm>
+          <a:prstGeom prst="roundRect">
+            <a:avLst>
+              <a:gd name="adj" fmla="val 6667"/>
+            </a:avLst>
+          </a:prstGeom>
+          <a:solidFill>
+            <a:srgbClr val="F4F7FA"/>
+          </a:solidFill>
+          <a:ln w="12700">
+            <a:solidFill>
+              <a:srgbClr val="DCE4EC"/>
+            </a:solidFill>
+            <a:prstDash val="solid"/>
+          </a:ln>
+        </p:spPr>
+      </p:sp>
+      <p:sp>
+        <p:nvSpPr>
+          <p:cNvPr id="13" name="Text 11"/>
+          <p:cNvSpPr txBox="1"/>
+          <p:nvPr/>
+        </p:nvSpPr>
+        <p:spPr>
+          <a:xfrm>
+            <a:off x="960120" y="3886200"/>
+            <a:ext cx="2834640" cy="457200"/>
+          </a:xfrm>
+          <a:prstGeom prst="rect">
+            <a:avLst/>
+          </a:prstGeom>
+          <a:noFill/>
+          <a:ln/>
+        </p:spPr>
+        <p:txBody>
+          <a:bodyPr wrap="square" lIns="0" tIns="0" rIns="0" bIns="0" rtlCol="0" anchor="ctr"/>
+          <a:lstStyle/>
+          <a:p>
+            <a:pPr marL="0" indent="0">
+              <a:buNone/>
+            </a:pPr>
+            <a:r>
+              <a:rPr lang="en-US" sz="1800" b="1" dirty="0">
+                <a:solidFill>
+                  <a:srgbClr val="21295C"/>
+                </a:solidFill>
+                <a:latin typeface="Cambria" pitchFamily="34" charset="0"/>
+                <a:ea typeface="Cambria" pitchFamily="34" charset="-122"/>
+                <a:cs typeface="Cambria" pitchFamily="34" charset="-120"/>
+              </a:rPr>
+              <a:t>ResNet18 → ResNet34</a:t>
+            </a:r>
+            <a:endParaRPr lang="en-US" sz="1800" dirty="0"/>
+          </a:p>
+        </p:txBody>
+      </p:sp>
+      <p:sp>
+        <p:nvSpPr>
+          <p:cNvPr id="14" name="Text 12"/>
+          <p:cNvSpPr txBox="1"/>
+          <p:nvPr/>
+        </p:nvSpPr>
+        <p:spPr>
+          <a:xfrm>
+            <a:off x="4023360" y="3657600"/>
+            <a:ext cx="2194560" cy="274320"/>
+          </a:xfrm>
+          <a:prstGeom prst="rect">
+            <a:avLst/>
+          </a:prstGeom>
+          <a:noFill/>
+          <a:ln/>
+        </p:spPr>
+        <p:txBody>
+          <a:bodyPr wrap="square" lIns="0" tIns="0" rIns="0" bIns="0" rtlCol="0" anchor="ctr"/>
+          <a:lstStyle/>
+          <a:p>
+            <a:pPr marL="0" indent="0">
+              <a:buNone/>
+            </a:pPr>
+            <a:r>
+              <a:rPr lang="en-US" sz="1100" b="1" kern="0" spc="100" dirty="0">
+                <a:solidFill>
+                  <a:srgbClr val="8A99A8"/>
+                </a:solidFill>
+                <a:latin typeface="Calibri" pitchFamily="34" charset="0"/>
+                <a:ea typeface="Calibri" pitchFamily="34" charset="-122"/>
+                <a:cs typeface="Calibri" pitchFamily="34" charset="-120"/>
+              </a:rPr>
+              <a:t>RMSE (m)</a:t>
+            </a:r>
+            <a:endParaRPr lang="en-US" sz="1100" dirty="0"/>
+          </a:p>
+        </p:txBody>
+      </p:sp>
+      <p:sp>
+        <p:nvSpPr>
+          <p:cNvPr id="15" name="Text 13"/>
+          <p:cNvSpPr txBox="1"/>
+          <p:nvPr/>
+        </p:nvSpPr>
+        <p:spPr>
+          <a:xfrm>
+            <a:off x="4023360" y="3977640"/>
+            <a:ext cx="2377440" cy="457200"/>
+          </a:xfrm>
+          <a:prstGeom prst="rect">
+            <a:avLst/>
+          </a:prstGeom>
+          <a:noFill/>
+          <a:ln/>
+        </p:spPr>
+        <p:txBody>
+          <a:bodyPr wrap="square" lIns="0" tIns="0" rIns="0" bIns="0" rtlCol="0" anchor="ctr"/>
+          <a:lstStyle/>
+          <a:p>
+            <a:pPr marL="0" indent="0">
+              <a:buNone/>
+            </a:pPr>
+            <a:r>
+              <a:rPr lang="en-US" sz="2200" b="1" dirty="0">
+                <a:solidFill>
+                  <a:srgbClr val="2E7D4F"/>
+                </a:solidFill>
+                <a:latin typeface="Cambria" pitchFamily="34" charset="0"/>
+                <a:ea typeface="Cambria" pitchFamily="34" charset="-122"/>
+                <a:cs typeface="Cambria" pitchFamily="34" charset="-120"/>
+              </a:rPr>
+              <a:t>0.691  →  0.597</a:t>
+            </a:r>
+            <a:endParaRPr lang="en-US" sz="2200" dirty="0"/>
+          </a:p>
+        </p:txBody>
+      </p:sp>
+      <p:sp>
+        <p:nvSpPr>
+          <p:cNvPr id="16" name="Text 14"/>
+          <p:cNvSpPr txBox="1"/>
+          <p:nvPr/>
+        </p:nvSpPr>
+        <p:spPr>
+          <a:xfrm>
+            <a:off x="6172200" y="4087368"/>
+            <a:ext cx="1280160" cy="274320"/>
+          </a:xfrm>
+          <a:prstGeom prst="rect">
+            <a:avLst/>
+          </a:prstGeom>
+          <a:noFill/>
+          <a:ln/>
+        </p:spPr>
+        <p:txBody>
+          <a:bodyPr wrap="square" lIns="0" tIns="0" rIns="0" bIns="0" rtlCol="0" anchor="ctr"/>
+          <a:lstStyle/>
+          <a:p>
+            <a:pPr marL="0" indent="0">
+              <a:buNone/>
+            </a:pPr>
+            <a:r>
+              <a:rPr lang="en-US" sz="1200" i="1" dirty="0">
+                <a:solidFill>
+                  <a:srgbClr val="2E7D4F"/>
+                </a:solidFill>
+                <a:latin typeface="Calibri" pitchFamily="34" charset="0"/>
+                <a:ea typeface="Calibri" pitchFamily="34" charset="-122"/>
+                <a:cs typeface="Calibri" pitchFamily="34" charset="-120"/>
+              </a:rPr>
+              <a:t>improved</a:t>
+            </a:r>
+            <a:endParaRPr lang="en-US" sz="1200" dirty="0"/>
+          </a:p>
+        </p:txBody>
+      </p:sp>
+      <p:sp>
+        <p:nvSpPr>
+          <p:cNvPr id="17" name="Text 15"/>
+          <p:cNvSpPr txBox="1"/>
+          <p:nvPr/>
+        </p:nvSpPr>
+        <p:spPr>
+          <a:xfrm>
+            <a:off x="7772400" y="3657600"/>
+            <a:ext cx="2194560" cy="274320"/>
+          </a:xfrm>
+          <a:prstGeom prst="rect">
+            <a:avLst/>
+          </a:prstGeom>
+          <a:noFill/>
+          <a:ln/>
+        </p:spPr>
+        <p:txBody>
+          <a:bodyPr wrap="square" lIns="0" tIns="0" rIns="0" bIns="0" rtlCol="0" anchor="ctr"/>
+          <a:lstStyle/>
+          <a:p>
+            <a:pPr marL="0" indent="0">
+              <a:buNone/>
+            </a:pPr>
+            <a:r>
+              <a:rPr lang="en-US" sz="1100" b="1" kern="0" spc="100" dirty="0">
+                <a:solidFill>
+                  <a:srgbClr val="8A99A8"/>
+                </a:solidFill>
+                <a:latin typeface="Calibri" pitchFamily="34" charset="0"/>
+                <a:ea typeface="Calibri" pitchFamily="34" charset="-122"/>
+                <a:cs typeface="Calibri" pitchFamily="34" charset="-120"/>
+              </a:rPr>
+              <a:t>AUROC</a:t>
+            </a:r>
+            <a:endParaRPr lang="en-US" sz="1100" dirty="0"/>
+          </a:p>
+        </p:txBody>
+      </p:sp>
+      <p:sp>
+        <p:nvSpPr>
+          <p:cNvPr id="18" name="Text 16"/>
+          <p:cNvSpPr txBox="1"/>
+          <p:nvPr/>
+        </p:nvSpPr>
+        <p:spPr>
+          <a:xfrm>
+            <a:off x="7772400" y="3977640"/>
+            <a:ext cx="2377440" cy="457200"/>
+          </a:xfrm>
+          <a:prstGeom prst="rect">
+            <a:avLst/>
+          </a:prstGeom>
+          <a:noFill/>
+          <a:ln/>
+        </p:spPr>
+        <p:txBody>
+          <a:bodyPr wrap="square" lIns="0" tIns="0" rIns="0" bIns="0" rtlCol="0" anchor="ctr"/>
+          <a:lstStyle/>
+          <a:p>
+            <a:pPr marL="0" indent="0">
+              <a:buNone/>
+            </a:pPr>
+            <a:r>
+              <a:rPr lang="en-US" sz="2200" b="1" dirty="0">
+                <a:solidFill>
+                  <a:srgbClr val="C4564F"/>
+                </a:solidFill>
+                <a:latin typeface="Cambria" pitchFamily="34" charset="0"/>
+                <a:ea typeface="Cambria" pitchFamily="34" charset="-122"/>
+                <a:cs typeface="Cambria" pitchFamily="34" charset="-120"/>
+              </a:rPr>
+              <a:t>0.986  →  0.956</a:t>
+            </a:r>
+            <a:endParaRPr lang="en-US" sz="2200" dirty="0"/>
+          </a:p>
+        </p:txBody>
+      </p:sp>
+      <p:sp>
+        <p:nvSpPr>
+          <p:cNvPr id="19" name="Text 17"/>
+          <p:cNvSpPr txBox="1"/>
+          <p:nvPr/>
+        </p:nvSpPr>
+        <p:spPr>
+          <a:xfrm>
+            <a:off x="9921240" y="4087368"/>
+            <a:ext cx="1371600" cy="274320"/>
+          </a:xfrm>
+          <a:prstGeom prst="rect">
+            <a:avLst/>
+          </a:prstGeom>
+          <a:noFill/>
+          <a:ln/>
+        </p:spPr>
+        <p:txBody>
+          <a:bodyPr wrap="square" lIns="0" tIns="0" rIns="0" bIns="0" rtlCol="0" anchor="ctr"/>
+          <a:lstStyle/>
+          <a:p>
+            <a:pPr marL="0" indent="0">
+              <a:buNone/>
+            </a:pPr>
+            <a:r>
+              <a:rPr lang="en-US" sz="1200" i="1" dirty="0">
+                <a:solidFill>
+                  <a:srgbClr val="C4564F"/>
+                </a:solidFill>
+                <a:latin typeface="Calibri" pitchFamily="34" charset="0"/>
+                <a:ea typeface="Calibri" pitchFamily="34" charset="-122"/>
+                <a:cs typeface="Calibri" pitchFamily="34" charset="-120"/>
+              </a:rPr>
+              <a:t>degraded</a:t>
+            </a:r>
+            <a:endParaRPr lang="en-US" sz="1200" dirty="0"/>
+          </a:p>
+        </p:txBody>
+      </p:sp>
+      <p:sp>
+        <p:nvSpPr>
+          <p:cNvPr id="20" name="Shape 18"/>
+          <p:cNvSpPr/>
+          <p:nvPr/>
+        </p:nvSpPr>
+        <p:spPr>
+          <a:xfrm>
+            <a:off x="640080" y="5029200"/>
+            <a:ext cx="10881360" cy="914400"/>
+          </a:xfrm>
+          <a:prstGeom prst="roundRect">
+            <a:avLst>
+              <a:gd name="adj" fmla="val 8000"/>
+            </a:avLst>
+          </a:prstGeom>
+          <a:solidFill>
+            <a:srgbClr val="FDF4E6"/>
+          </a:solidFill>
+          <a:ln w="12700">
+            <a:solidFill>
+              <a:srgbClr val="E8A33D"/>
+            </a:solidFill>
+            <a:prstDash val="solid"/>
+          </a:ln>
+        </p:spPr>
+      </p:sp>
+      <p:sp>
+        <p:nvSpPr>
+          <p:cNvPr id="21" name="Text 19"/>
+          <p:cNvSpPr txBox="1"/>
+          <p:nvPr/>
+        </p:nvSpPr>
+        <p:spPr>
+          <a:xfrm>
+            <a:off x="960120" y="5230368"/>
+            <a:ext cx="10241280" cy="548640"/>
+          </a:xfrm>
+          <a:prstGeom prst="rect">
+            <a:avLst/>
+          </a:prstGeom>
+          <a:noFill/>
+          <a:ln/>
+        </p:spPr>
+        <p:txBody>
+          <a:bodyPr wrap="square" lIns="0" tIns="0" rIns="0" bIns="0" rtlCol="0" anchor="ctr"/>
+          <a:lstStyle/>
+          <a:p>
+            <a:pPr marL="0" indent="0">
+              <a:lnSpc>
+                <a:spcPts val="1900"/>
+              </a:lnSpc>
+              <a:buNone/>
+            </a:pPr>
+            <a:r>
+              <a:rPr lang="en-US" sz="1400" b="1" dirty="0">
+                <a:solidFill>
+                  <a:srgbClr val="8A5A12"/>
+                </a:solidFill>
+                <a:latin typeface="Calibri" pitchFamily="34" charset="0"/>
+                <a:ea typeface="Calibri" pitchFamily="34" charset="-122"/>
+                <a:cs typeface="Calibri" pitchFamily="34" charset="-120"/>
+              </a:rPr>
+              <a:t>A model that generalises better responds more consistently to unfamiliar input — which is exactly the signal the score reads. Robustness and detectability appear to pull against each other.</a:t>
+            </a:r>
+            <a:endParaRPr lang="en-US" sz="1400" dirty="0"/>
+          </a:p>
+        </p:txBody>
+      </p:sp>
+    </p:spTree>
+  </p:cSld>
+  <p:clrMapOvr>
+    <a:masterClrMapping/>
+  </p:clrMapOvr>
+</p:sld>
+</file>
+
+<file path=ppt/slides/slide9.xml><?xml version="1.0" encoding="utf-8"?>
+<p:sld xmlns:a="http://schemas.openxmlformats.org/drawingml/2006/main" xmlns:r="http://schemas.openxmlformats.org/officeDocument/2006/relationships" xmlns:p="http://schemas.openxmlformats.org/presentationml/2006/main">
+  <p:cSld name="Slide 9">
+    <p:bg>
+      <p:bgPr>
+        <a:solidFill>
+          <a:srgbClr val="21295C"/>
+        </a:solidFill>
+        <a:effectLst/>
+      </p:bgPr>
+    </p:bg>
+    <p:spTree>
+      <p:nvGrpSpPr>
+        <p:cNvPr id="1" name=""/>
+        <p:cNvGrpSpPr/>
+        <p:nvPr/>
+      </p:nvGrpSpPr>
+      <p:grpSpPr>
+        <a:xfrm>
+          <a:off x="0" y="0"/>
+          <a:ext cx="0" cy="0"/>
+          <a:chOff x="0" y="0"/>
+          <a:chExt cx="0" cy="0"/>
+        </a:xfrm>
+      </p:grpSpPr>
+      <p:sp>
+        <p:nvSpPr>
+          <p:cNvPr id="2" name="Text 0"/>
+          <p:cNvSpPr txBox="1"/>
+          <p:nvPr/>
+        </p:nvSpPr>
+        <p:spPr>
+          <a:xfrm>
+            <a:off x="640080" y="502920"/>
+            <a:ext cx="9144000" cy="548640"/>
+          </a:xfrm>
+          <a:prstGeom prst="rect">
+            <a:avLst/>
+          </a:prstGeom>
+          <a:noFill/>
+          <a:ln/>
+        </p:spPr>
+        <p:txBody>
+          <a:bodyPr wrap="square" lIns="0" tIns="0" rIns="0" bIns="0" rtlCol="0" anchor="ctr"/>
+          <a:lstStyle/>
+          <a:p>
+            <a:pPr marL="0" indent="0">
+              <a:buNone/>
+            </a:pPr>
+            <a:r>
+              <a:rPr lang="en-US" sz="3800" b="1" dirty="0">
+                <a:solidFill>
+                  <a:srgbClr val="FFFFFF"/>
+                </a:solidFill>
+                <a:latin typeface="Cambria" pitchFamily="34" charset="0"/>
+                <a:ea typeface="Cambria" pitchFamily="34" charset="-122"/>
+                <a:cs typeface="Cambria" pitchFamily="34" charset="-120"/>
+              </a:rPr>
               <a:t>Where this stands</a:t>
             </a:r>
             <a:endParaRPr lang="en-US" sz="3800" dirty="0"/>
@@ -6563,11 +8113,11 @@
           <a:bodyPr wrap="square" lIns="0" tIns="0" rIns="0" bIns="0" rtlCol="0" anchor="ctr"/>
           <a:lstStyle/>
           <a:p>
-            <a:pPr indent="0" marL="0">
-              <a:buNone/>
-            </a:pPr>
-            <a:r>
-              <a:rPr lang="en-US" sz="1100" b="1" spc="100" kern="0" dirty="0">
+            <a:pPr marL="0" indent="0">
+              <a:buNone/>
+            </a:pPr>
+            <a:r>
+              <a:rPr lang="en-US" sz="1100" b="1" kern="0" spc="100" dirty="0">
                 <a:solidFill>
                   <a:srgbClr val="E8A33D"/>
                 </a:solidFill>
@@ -6621,7 +8171,7 @@
                 <a:ea typeface="Calibri" pitchFamily="34" charset="-122"/>
                 <a:cs typeface="Calibri" pitchFamily="34" charset="-120"/>
               </a:rPr>
-              <a:t>Strong separation without retraining or OOD access</a:t>
+              <a:t>AUROC 0.986 without retraining or OOD access</a:t>
             </a:r>
             <a:endParaRPr lang="en-US" sz="1400" dirty="0"/>
           </a:p>
@@ -6669,7 +8219,7 @@
                 <a:ea typeface="Calibri" pitchFamily="34" charset="-122"/>
                 <a:cs typeface="Calibri" pitchFamily="34" charset="-120"/>
               </a:rPr>
-              <a:t>Layer-wise ablation obtained from a single inference pass</a:t>
+              <a:t>Layer and architecture ablation from single inference passes</a:t>
             </a:r>
             <a:endParaRPr lang="en-US" sz="1400" dirty="0"/>
           </a:p>
@@ -6720,11 +8270,11 @@
           <a:bodyPr wrap="square" lIns="0" tIns="0" rIns="0" bIns="0" rtlCol="0" anchor="ctr"/>
           <a:lstStyle/>
           <a:p>
-            <a:pPr indent="0" marL="0">
-              <a:buNone/>
-            </a:pPr>
-            <a:r>
-              <a:rPr lang="en-US" sz="1100" b="1" spc="100" kern="0" dirty="0">
+            <a:pPr marL="0" indent="0">
+              <a:buNone/>
+            </a:pPr>
+            <a:r>
+              <a:rPr lang="en-US" sz="1100" b="1" kern="0" spc="100" dirty="0">
                 <a:solidFill>
                   <a:srgbClr val="E86A6A"/>
                 </a:solidFill>
@@ -6778,7 +8328,7 @@
                 <a:ea typeface="Calibri" pitchFamily="34" charset="-122"/>
                 <a:cs typeface="Calibri" pitchFamily="34" charset="-120"/>
               </a:rPr>
-              <a:t>One OOD source only — indoor/outdoor is a wide gap</a:t>
+              <a:t>One OOD source — indoor/outdoor is a wide gap</a:t>
             </a:r>
             <a:endParaRPr lang="en-US" sz="1400" dirty="0"/>
           </a:p>
@@ -6802,7 +8352,7 @@
                 <a:ea typeface="Calibri" pitchFamily="34" charset="-122"/>
                 <a:cs typeface="Calibri" pitchFamily="34" charset="-120"/>
               </a:rPr>
-              <a:t>Near-distribution shift (unseen rooms) untested</a:t>
+              <a:t>No depth metrics on KITTI: ground truth unavailable</a:t>
             </a:r>
             <a:endParaRPr lang="en-US" sz="1400" dirty="0"/>
           </a:p>
@@ -6826,7 +8376,7 @@
                 <a:ea typeface="Calibri" pitchFamily="34" charset="-122"/>
                 <a:cs typeface="Calibri" pitchFamily="34" charset="-120"/>
               </a:rPr>
-              <a:t>Mild overfitting on 1,159 training images</a:t>
+              <a:t>Near-distribution shift (unseen rooms) untested</a:t>
             </a:r>
             <a:endParaRPr lang="en-US" sz="1400" dirty="0"/>
           </a:p>
@@ -6904,11 +8454,11 @@
           <a:bodyPr wrap="square" lIns="0" tIns="0" rIns="0" bIns="0" rtlCol="0" anchor="ctr"/>
           <a:lstStyle/>
           <a:p>
-            <a:pPr indent="0" marL="0">
-              <a:buNone/>
-            </a:pPr>
-            <a:r>
-              <a:rPr lang="en-US" sz="1300" b="1" spc="100" kern="0" dirty="0">
+            <a:pPr marL="0" indent="0">
+              <a:buNone/>
+            </a:pPr>
+            <a:r>
+              <a:rPr lang="en-US" sz="1300" b="1" kern="0" spc="100" dirty="0">
                 <a:solidFill>
                   <a:srgbClr val="E8A33D"/>
                 </a:solidFill>
@@ -6943,7 +8493,7 @@
           <a:bodyPr wrap="square" lIns="0" tIns="0" rIns="0" bIns="0" rtlCol="0" anchor="ctr"/>
           <a:lstStyle/>
           <a:p>
-            <a:pPr indent="0" marL="0">
+            <a:pPr marL="0" indent="0">
               <a:lnSpc>
                 <a:spcPts val="1900"/>
               </a:lnSpc>
@@ -6958,7 +8508,7 @@
                 <a:ea typeface="Calibri" pitchFamily="34" charset="-122"/>
                 <a:cs typeface="Calibri" pitchFamily="34" charset="-120"/>
               </a:rPr>
-              <a:t>Harder OOD sources — different indoor datasets, synthetic corruptions, degraded capture — would separate genuine distribution shift from low-level texture difference. A second backbone would test whether the layer-3 advantage is architectural or specific to ResNet18.</a:t>
+              <a:t>Harder OOD sources — different indoor datasets, synthetic corruptions, degraded capture — would separate genuine distribution shift from low-level texture difference. A non-residual backbone would test whether the layer-migration effect is a property of depth or of the ResNet family specifically.</a:t>
             </a:r>
             <a:endParaRPr lang="en-US" sz="1400" dirty="0"/>
           </a:p>
@@ -7265,4 +8815,299 @@
     </a:ext>
   </a:extLst>
 </a:theme>
+</file>
+
+<file path=ppt/theme/theme2.xml><?xml version="1.0" encoding="utf-8"?>
+<a:theme xmlns:a="http://schemas.openxmlformats.org/drawingml/2006/main" name="Office Theme">
+  <a:themeElements>
+    <a:clrScheme name="Office">
+      <a:dk1>
+        <a:sysClr val="windowText" lastClr="000000"/>
+      </a:dk1>
+      <a:lt1>
+        <a:sysClr val="window" lastClr="FFFFFF"/>
+      </a:lt1>
+      <a:dk2>
+        <a:srgbClr val="44546A"/>
+      </a:dk2>
+      <a:lt2>
+        <a:srgbClr val="E7E6E6"/>
+      </a:lt2>
+      <a:accent1>
+        <a:srgbClr val="4472C4"/>
+      </a:accent1>
+      <a:accent2>
+        <a:srgbClr val="ED7D31"/>
+      </a:accent2>
+      <a:accent3>
+        <a:srgbClr val="A5A5A5"/>
+      </a:accent3>
+      <a:accent4>
+        <a:srgbClr val="FFC000"/>
+      </a:accent4>
+      <a:accent5>
+        <a:srgbClr val="5B9BD5"/>
+      </a:accent5>
+      <a:accent6>
+        <a:srgbClr val="70AD47"/>
+      </a:accent6>
+      <a:hlink>
+        <a:srgbClr val="0563C1"/>
+      </a:hlink>
+      <a:folHlink>
+        <a:srgbClr val="954F72"/>
+      </a:folHlink>
+    </a:clrScheme>
+    <a:fontScheme name="Office">
+      <a:majorFont>
+        <a:latin typeface="Calibri Light" panose="020F0302020204030204"/>
+        <a:ea typeface=""/>
+        <a:cs typeface=""/>
+        <a:font script="Jpan" typeface="游ゴシック Light"/>
+        <a:font script="Hang" typeface="맑은 고딕"/>
+        <a:font script="Hans" typeface="等线 Light"/>
+        <a:font script="Hant" typeface="新細明體"/>
+        <a:font script="Arab" typeface="Times New Roman"/>
+        <a:font script="Hebr" typeface="Times New Roman"/>
+        <a:font script="Thai" typeface="Angsana New"/>
+        <a:font script="Ethi" typeface="Nyala"/>
+        <a:font script="Beng" typeface="Vrinda"/>
+        <a:font script="Gujr" typeface="Shruti"/>
+        <a:font script="Khmr" typeface="MoolBoran"/>
+        <a:font script="Knda" typeface="Tunga"/>
+        <a:font script="Guru" typeface="Raavi"/>
+        <a:font script="Cans" typeface="Euphemia"/>
+        <a:font script="Cher" typeface="Plantagenet Cherokee"/>
+        <a:font script="Yiii" typeface="Microsoft Yi Baiti"/>
+        <a:font script="Tibt" typeface="Microsoft Himalaya"/>
+        <a:font script="Thaa" typeface="MV Boli"/>
+        <a:font script="Deva" typeface="Mangal"/>
+        <a:font script="Telu" typeface="Gautami"/>
+        <a:font script="Taml" typeface="Latha"/>
+        <a:font script="Syrc" typeface="Estrangelo Edessa"/>
+        <a:font script="Orya" typeface="Kalinga"/>
+        <a:font script="Mlym" typeface="Kartika"/>
+        <a:font script="Laoo" typeface="DokChampa"/>
+        <a:font script="Sinh" typeface="Iskoola Pota"/>
+        <a:font script="Mong" typeface="Mongolian Baiti"/>
+        <a:font script="Viet" typeface="Times New Roman"/>
+        <a:font script="Uigh" typeface="Microsoft Uighur"/>
+        <a:font script="Geor" typeface="Sylfaen"/>
+        <a:font script="Armn" typeface="Arial"/>
+        <a:font script="Bugi" typeface="Leelawadee UI"/>
+        <a:font script="Bopo" typeface="Microsoft JhengHei"/>
+        <a:font script="Java" typeface="Javanese Text"/>
+        <a:font script="Lisu" typeface="Segoe UI"/>
+        <a:font script="Mymr" typeface="Myanmar Text"/>
+        <a:font script="Nkoo" typeface="Ebrima"/>
+        <a:font script="Olck" typeface="Nirmala UI"/>
+        <a:font script="Osma" typeface="Ebrima"/>
+        <a:font script="Phag" typeface="Phagspa"/>
+        <a:font script="Syrn" typeface="Estrangelo Edessa"/>
+        <a:font script="Syrj" typeface="Estrangelo Edessa"/>
+        <a:font script="Syre" typeface="Estrangelo Edessa"/>
+        <a:font script="Sora" typeface="Nirmala UI"/>
+        <a:font script="Tale" typeface="Microsoft Tai Le"/>
+        <a:font script="Talu" typeface="Microsoft New Tai Lue"/>
+        <a:font script="Tfng" typeface="Ebrima"/>
+      </a:majorFont>
+      <a:minorFont>
+        <a:latin typeface="Calibri" panose="020F0502020204030204"/>
+        <a:ea typeface=""/>
+        <a:cs typeface=""/>
+        <a:font script="Jpan" typeface="游ゴシック"/>
+        <a:font script="Hang" typeface="맑은 고딕"/>
+        <a:font script="Hans" typeface="等线"/>
+        <a:font script="Hant" typeface="新細明體"/>
+        <a:font script="Arab" typeface="Arial"/>
+        <a:font script="Hebr" typeface="Arial"/>
+        <a:font script="Thai" typeface="Cordia New"/>
+        <a:font script="Ethi" typeface="Nyala"/>
+        <a:font script="Beng" typeface="Vrinda"/>
+        <a:font script="Gujr" typeface="Shruti"/>
+        <a:font script="Khmr" typeface="DaunPenh"/>
+        <a:font script="Knda" typeface="Tunga"/>
+        <a:font script="Guru" typeface="Raavi"/>
+        <a:font script="Cans" typeface="Euphemia"/>
+        <a:font script="Cher" typeface="Plantagenet Cherokee"/>
+        <a:font script="Yiii" typeface="Microsoft Yi Baiti"/>
+        <a:font script="Tibt" typeface="Microsoft Himalaya"/>
+        <a:font script="Thaa" typeface="MV Boli"/>
+        <a:font script="Deva" typeface="Mangal"/>
+        <a:font script="Telu" typeface="Gautami"/>
+        <a:font script="Taml" typeface="Latha"/>
+        <a:font script="Syrc" typeface="Estrangelo Edessa"/>
+        <a:font script="Orya" typeface="Kalinga"/>
+        <a:font script="Mlym" typeface="Kartika"/>
+        <a:font script="Laoo" typeface="DokChampa"/>
+        <a:font script="Sinh" typeface="Iskoola Pota"/>
+        <a:font script="Mong" typeface="Mongolian Baiti"/>
+        <a:font script="Viet" typeface="Arial"/>
+        <a:font script="Uigh" typeface="Microsoft Uighur"/>
+        <a:font script="Geor" typeface="Sylfaen"/>
+        <a:font script="Armn" typeface="Arial"/>
+        <a:font script="Bugi" typeface="Leelawadee UI"/>
+        <a:font script="Bopo" typeface="Microsoft JhengHei"/>
+        <a:font script="Java" typeface="Javanese Text"/>
+        <a:font script="Lisu" typeface="Segoe UI"/>
+        <a:font script="Mymr" typeface="Myanmar Text"/>
+        <a:font script="Nkoo" typeface="Ebrima"/>
+        <a:font script="Olck" typeface="Nirmala UI"/>
+        <a:font script="Osma" typeface="Ebrima"/>
+        <a:font script="Phag" typeface="Phagspa"/>
+        <a:font script="Syrn" typeface="Estrangelo Edessa"/>
+        <a:font script="Syrj" typeface="Estrangelo Edessa"/>
+        <a:font script="Syre" typeface="Estrangelo Edessa"/>
+        <a:font script="Sora" typeface="Nirmala UI"/>
+        <a:font script="Tale" typeface="Microsoft Tai Le"/>
+        <a:font script="Talu" typeface="Microsoft New Tai Lue"/>
+        <a:font script="Tfng" typeface="Ebrima"/>
+      </a:minorFont>
+    </a:fontScheme>
+    <a:fmtScheme name="Office">
+      <a:fillStyleLst>
+        <a:solidFill>
+          <a:schemeClr val="phClr"/>
+        </a:solidFill>
+        <a:gradFill rotWithShape="1">
+          <a:gsLst>
+            <a:gs pos="0">
+              <a:schemeClr val="phClr">
+                <a:lumMod val="110000"/>
+                <a:satMod val="105000"/>
+                <a:tint val="67000"/>
+              </a:schemeClr>
+            </a:gs>
+            <a:gs pos="50000">
+              <a:schemeClr val="phClr">
+                <a:lumMod val="105000"/>
+                <a:satMod val="103000"/>
+                <a:tint val="73000"/>
+              </a:schemeClr>
+            </a:gs>
+            <a:gs pos="100000">
+              <a:schemeClr val="phClr">
+                <a:lumMod val="105000"/>
+                <a:satMod val="109000"/>
+                <a:tint val="81000"/>
+              </a:schemeClr>
+            </a:gs>
+          </a:gsLst>
+          <a:lin ang="5400000" scaled="0"/>
+        </a:gradFill>
+        <a:gradFill rotWithShape="1">
+          <a:gsLst>
+            <a:gs pos="0">
+              <a:schemeClr val="phClr">
+                <a:satMod val="103000"/>
+                <a:lumMod val="102000"/>
+                <a:tint val="94000"/>
+              </a:schemeClr>
+            </a:gs>
+            <a:gs pos="50000">
+              <a:schemeClr val="phClr">
+                <a:satMod val="110000"/>
+                <a:lumMod val="100000"/>
+                <a:shade val="100000"/>
+              </a:schemeClr>
+            </a:gs>
+            <a:gs pos="100000">
+              <a:schemeClr val="phClr">
+                <a:lumMod val="99000"/>
+                <a:satMod val="120000"/>
+                <a:shade val="78000"/>
+              </a:schemeClr>
+            </a:gs>
+          </a:gsLst>
+          <a:lin ang="5400000" scaled="0"/>
+        </a:gradFill>
+      </a:fillStyleLst>
+      <a:lnStyleLst>
+        <a:ln w="6350" cap="flat" cmpd="sng" algn="ctr">
+          <a:solidFill>
+            <a:schemeClr val="phClr"/>
+          </a:solidFill>
+          <a:prstDash val="solid"/>
+          <a:miter lim="800000"/>
+        </a:ln>
+        <a:ln w="12700" cap="flat" cmpd="sng" algn="ctr">
+          <a:solidFill>
+            <a:schemeClr val="phClr"/>
+          </a:solidFill>
+          <a:prstDash val="solid"/>
+          <a:miter lim="800000"/>
+        </a:ln>
+        <a:ln w="19050" cap="flat" cmpd="sng" algn="ctr">
+          <a:solidFill>
+            <a:schemeClr val="phClr"/>
+          </a:solidFill>
+          <a:prstDash val="solid"/>
+          <a:miter lim="800000"/>
+        </a:ln>
+      </a:lnStyleLst>
+      <a:effectStyleLst>
+        <a:effectStyle>
+          <a:effectLst/>
+        </a:effectStyle>
+        <a:effectStyle>
+          <a:effectLst/>
+        </a:effectStyle>
+        <a:effectStyle>
+          <a:effectLst>
+            <a:outerShdw blurRad="57150" dist="19050" dir="5400000" algn="ctr" rotWithShape="0">
+              <a:srgbClr val="000000">
+                <a:alpha val="63000"/>
+              </a:srgbClr>
+            </a:outerShdw>
+          </a:effectLst>
+        </a:effectStyle>
+      </a:effectStyleLst>
+      <a:bgFillStyleLst>
+        <a:solidFill>
+          <a:schemeClr val="phClr"/>
+        </a:solidFill>
+        <a:solidFill>
+          <a:schemeClr val="phClr">
+            <a:tint val="95000"/>
+            <a:satMod val="170000"/>
+          </a:schemeClr>
+        </a:solidFill>
+        <a:gradFill rotWithShape="1">
+          <a:gsLst>
+            <a:gs pos="0">
+              <a:schemeClr val="phClr">
+                <a:tint val="93000"/>
+                <a:satMod val="150000"/>
+                <a:shade val="98000"/>
+                <a:lumMod val="102000"/>
+              </a:schemeClr>
+            </a:gs>
+            <a:gs pos="50000">
+              <a:schemeClr val="phClr">
+                <a:tint val="98000"/>
+                <a:satMod val="130000"/>
+                <a:shade val="90000"/>
+                <a:lumMod val="103000"/>
+              </a:schemeClr>
+            </a:gs>
+            <a:gs pos="100000">
+              <a:schemeClr val="phClr">
+                <a:shade val="63000"/>
+                <a:satMod val="120000"/>
+              </a:schemeClr>
+            </a:gs>
+          </a:gsLst>
+          <a:lin ang="5400000" scaled="0"/>
+        </a:gradFill>
+      </a:bgFillStyleLst>
+    </a:fmtScheme>
+  </a:themeElements>
+  <a:objectDefaults/>
+  <a:extraClrSchemeLst/>
+  <a:extLst>
+    <a:ext uri="{05A4C25C-085E-4340-85A3-A5531E510DB2}">
+      <thm15:themeFamily xmlns:thm15="http://schemas.microsoft.com/office/thememl/2012/main" name="Office Theme" id="{62F939B6-93AF-4DB8-9C6B-D6C7DFDC589F}" vid="{4A3C46E8-61CC-4603-A589-7422A47A8E4A}"/>
+    </a:ext>
+  </a:extLst>
+</a:theme>
 </file>
</xml_diff>